<commit_message>
feat(dashboard,pptx): FDP 제품·기술 축 — 대시보드 섹션 2카드 + PPT 슬라이드 2장 (v2.33.0)
- devTransformation.js DT_FDP 신설, 개발실 전환 탭에 FDP 개요·실행전략 카드 추가
- 다운로드 4번째 항목(제품·기술 축 FDP 2장) + 그리드 4열
- PPT 통합본 5장(제품 축 ①전환·6요소 / ②실행전략 6종·핵심 KPI), 개별본 -fdp 신규
- version v2.33.0 (마이너 — 새 데이터 카테고리), npm run build 검증

Co-Authored-By: Claude Fable 5 <noreply@anthropic.com>
Claude-Session: https://claude.ai/code/session_01P75FajBNDiW5p24ay2HU9V
</commit_message>
<xml_diff>
--- a/outputs/presentation/dev-transformation-summary.pptx
+++ b/outputs/presentation/dev-transformation-summary.pptx
@@ -8,9 +8,11 @@
     <p:sldId id="256" r:id="rId2"/>
     <p:sldId id="257" r:id="rId3"/>
     <p:sldId id="258" r:id="rId4"/>
+    <p:sldId id="259" r:id="rId5"/>
+    <p:sldId id="260" r:id="rId6"/>
   </p:sldIdLst>
   <p:notesMasterIdLst>
-    <p:notesMasterId r:id="rId5"/>
+    <p:notesMasterId r:id="rId7"/>
   </p:notesMasterIdLst>
   <p:sldSz cx="12192000" cy="6858000"/>
   <p:notesSz cx="6858000" cy="12192000"/>
@@ -722,6 +724,182 @@
 </p:notes>
 </file>
 
+<file path=ppt/notesSlides/notesSlide4.xml><?xml version="1.0" encoding="utf-8"?>
+<p:notes xmlns:a="http://schemas.openxmlformats.org/drawingml/2006/main" xmlns:r="http://schemas.openxmlformats.org/officeDocument/2006/relationships" xmlns:p="http://schemas.openxmlformats.org/presentationml/2006/main">
+  <p:cSld>
+    <p:spTree>
+      <p:nvGrpSpPr>
+        <p:cNvPr id="1" name=""/>
+        <p:cNvGrpSpPr/>
+        <p:nvPr/>
+      </p:nvGrpSpPr>
+      <p:grpSpPr>
+        <a:xfrm>
+          <a:off x="0" y="0"/>
+          <a:ext cx="0" cy="0"/>
+          <a:chOff x="0" y="0"/>
+          <a:chExt cx="0" cy="0"/>
+        </a:xfrm>
+      </p:grpSpPr>
+      <p:sp>
+        <p:nvSpPr>
+          <p:cNvPr id="2" name="Slide Image Placeholder 1"/>
+          <p:cNvSpPr>
+            <a:spLocks noGrp="1" noRot="1" noChangeAspect="1"/>
+          </p:cNvSpPr>
+          <p:nvPr>
+            <p:ph type="sldImg"/>
+          </p:nvPr>
+        </p:nvSpPr>
+        <p:spPr/>
+      </p:sp>
+      <p:sp>
+        <p:nvSpPr>
+          <p:cNvPr id="3" name="Notes Placeholder 2"/>
+          <p:cNvSpPr>
+            <a:spLocks noGrp="1"/>
+          </p:cNvSpPr>
+          <p:nvPr>
+            <p:ph type="body" idx="1"/>
+          </p:nvPr>
+        </p:nvSpPr>
+        <p:spPr/>
+        <p:txBody>
+          <a:bodyPr/>
+          <a:lstStyle/>
+          <a:p>
+            <a:r>
+              <a:rPr lang="en-US" dirty="0"/>
+              <a:t/>
+            </a:r>
+            <a:endParaRPr lang="en-US" dirty="0"/>
+          </a:p>
+        </p:txBody>
+      </p:sp>
+      <p:sp>
+        <p:nvSpPr>
+          <p:cNvPr id="4" name="Slide Number Placeholder 3"/>
+          <p:cNvSpPr>
+            <a:spLocks noGrp="1"/>
+          </p:cNvSpPr>
+          <p:nvPr>
+            <p:ph type="sldNum" sz="quarter" idx="10"/>
+          </p:nvPr>
+        </p:nvSpPr>
+        <p:spPr/>
+        <p:txBody>
+          <a:bodyPr/>
+          <a:lstStyle/>
+          <a:p>
+            <a:fld id="{F7021451-1387-4CA6-816F-3879F97B5CBC}" type="slidenum">
+              <a:rPr lang="en-US"/>
+              <a:t>4</a:t>
+            </a:fld>
+            <a:endParaRPr lang="en-US"/>
+          </a:p>
+        </p:txBody>
+      </p:sp>
+    </p:spTree>
+    <p:extLst>
+      <p:ext uri="{BB962C8B-B14F-4D97-AF65-F5344CB8AC3E}">
+        <p14:creationId xmlns:p14="http://schemas.microsoft.com/office/powerpoint/2010/main" val="1024086991"/>
+      </p:ext>
+    </p:extLst>
+  </p:cSld>
+  <p:clrMapOvr>
+    <a:masterClrMapping/>
+  </p:clrMapOvr>
+</p:notes>
+</file>
+
+<file path=ppt/notesSlides/notesSlide5.xml><?xml version="1.0" encoding="utf-8"?>
+<p:notes xmlns:a="http://schemas.openxmlformats.org/drawingml/2006/main" xmlns:r="http://schemas.openxmlformats.org/officeDocument/2006/relationships" xmlns:p="http://schemas.openxmlformats.org/presentationml/2006/main">
+  <p:cSld>
+    <p:spTree>
+      <p:nvGrpSpPr>
+        <p:cNvPr id="1" name=""/>
+        <p:cNvGrpSpPr/>
+        <p:nvPr/>
+      </p:nvGrpSpPr>
+      <p:grpSpPr>
+        <a:xfrm>
+          <a:off x="0" y="0"/>
+          <a:ext cx="0" cy="0"/>
+          <a:chOff x="0" y="0"/>
+          <a:chExt cx="0" cy="0"/>
+        </a:xfrm>
+      </p:grpSpPr>
+      <p:sp>
+        <p:nvSpPr>
+          <p:cNvPr id="2" name="Slide Image Placeholder 1"/>
+          <p:cNvSpPr>
+            <a:spLocks noGrp="1" noRot="1" noChangeAspect="1"/>
+          </p:cNvSpPr>
+          <p:nvPr>
+            <p:ph type="sldImg"/>
+          </p:nvPr>
+        </p:nvSpPr>
+        <p:spPr/>
+      </p:sp>
+      <p:sp>
+        <p:nvSpPr>
+          <p:cNvPr id="3" name="Notes Placeholder 2"/>
+          <p:cNvSpPr>
+            <a:spLocks noGrp="1"/>
+          </p:cNvSpPr>
+          <p:nvPr>
+            <p:ph type="body" idx="1"/>
+          </p:nvPr>
+        </p:nvSpPr>
+        <p:spPr/>
+        <p:txBody>
+          <a:bodyPr/>
+          <a:lstStyle/>
+          <a:p>
+            <a:r>
+              <a:rPr lang="en-US" dirty="0"/>
+              <a:t/>
+            </a:r>
+            <a:endParaRPr lang="en-US" dirty="0"/>
+          </a:p>
+        </p:txBody>
+      </p:sp>
+      <p:sp>
+        <p:nvSpPr>
+          <p:cNvPr id="4" name="Slide Number Placeholder 3"/>
+          <p:cNvSpPr>
+            <a:spLocks noGrp="1"/>
+          </p:cNvSpPr>
+          <p:nvPr>
+            <p:ph type="sldNum" sz="quarter" idx="10"/>
+          </p:nvPr>
+        </p:nvSpPr>
+        <p:spPr/>
+        <p:txBody>
+          <a:bodyPr/>
+          <a:lstStyle/>
+          <a:p>
+            <a:fld id="{F7021451-1387-4CA6-816F-3879F97B5CBC}" type="slidenum">
+              <a:rPr lang="en-US"/>
+              <a:t>5</a:t>
+            </a:fld>
+            <a:endParaRPr lang="en-US"/>
+          </a:p>
+        </p:txBody>
+      </p:sp>
+    </p:spTree>
+    <p:extLst>
+      <p:ext uri="{BB962C8B-B14F-4D97-AF65-F5344CB8AC3E}">
+        <p14:creationId xmlns:p14="http://schemas.microsoft.com/office/powerpoint/2010/main" val="1024086991"/>
+      </p:ext>
+    </p:extLst>
+  </p:cSld>
+  <p:clrMapOvr>
+    <a:masterClrMapping/>
+  </p:clrMapOvr>
+</p:notes>
+</file>
+
 <file path=ppt/slideLayouts/slideLayout1.xml><?xml version="1.0" encoding="utf-8"?>
 <p:sldLayout xmlns:a="http://schemas.openxmlformats.org/drawingml/2006/main" xmlns:r="http://schemas.openxmlformats.org/officeDocument/2006/relationships" xmlns:p="http://schemas.openxmlformats.org/presentationml/2006/main" preserve="1">
   <p:cSld name="DEFAULT">
@@ -1055,7 +1233,7 @@
         <p:spPr>
           <a:xfrm>
             <a:off x="457200" y="237744"/>
-            <a:ext cx="9692640" cy="566928"/>
+            <a:ext cx="9994392" cy="566928"/>
           </a:xfrm>
           <a:prstGeom prst="rect">
             <a:avLst/>
@@ -3860,7 +4038,7 @@
         <p:spPr>
           <a:xfrm>
             <a:off x="457200" y="237744"/>
-            <a:ext cx="9692640" cy="566928"/>
+            <a:ext cx="9994392" cy="566928"/>
           </a:xfrm>
           <a:prstGeom prst="rect">
             <a:avLst/>
@@ -6093,7 +6271,7 @@
         <p:spPr>
           <a:xfrm>
             <a:off x="457200" y="237744"/>
-            <a:ext cx="9692640" cy="566928"/>
+            <a:ext cx="9994392" cy="566928"/>
           </a:xfrm>
           <a:prstGeom prst="rect">
             <a:avLst/>
@@ -7249,6 +7427,2761 @@
               <a:t>스타 영입 축적 → 조직 전반 수준 상향</a:t>
             </a:r>
             <a:endParaRPr lang="en-US" sz="1350" dirty="0"/>
+          </a:p>
+        </p:txBody>
+      </p:sp>
+    </p:spTree>
+  </p:cSld>
+  <p:clrMapOvr>
+    <a:masterClrMapping/>
+  </p:clrMapOvr>
+</p:sld>
+</file>
+
+<file path=ppt/slides/slide4.xml><?xml version="1.0" encoding="utf-8"?>
+<p:sld xmlns:a="http://schemas.openxmlformats.org/drawingml/2006/main" xmlns:r="http://schemas.openxmlformats.org/officeDocument/2006/relationships" xmlns:p="http://schemas.openxmlformats.org/presentationml/2006/main">
+  <p:cSld name="Slide 4">
+    <p:spTree>
+      <p:nvGrpSpPr>
+        <p:cNvPr id="1" name=""/>
+        <p:cNvGrpSpPr/>
+        <p:nvPr/>
+      </p:nvGrpSpPr>
+      <p:grpSpPr>
+        <a:xfrm>
+          <a:off x="0" y="0"/>
+          <a:ext cx="0" cy="0"/>
+          <a:chOff x="0" y="0"/>
+          <a:chExt cx="0" cy="0"/>
+        </a:xfrm>
+      </p:grpSpPr>
+      <p:sp>
+        <p:nvSpPr>
+          <p:cNvPr id="2" name="Text 0"/>
+          <p:cNvSpPr/>
+          <p:nvPr/>
+        </p:nvSpPr>
+        <p:spPr>
+          <a:xfrm>
+            <a:off x="457200" y="237744"/>
+            <a:ext cx="9765792" cy="566928"/>
+          </a:xfrm>
+          <a:prstGeom prst="rect">
+            <a:avLst/>
+          </a:prstGeom>
+          <a:noFill/>
+          <a:ln/>
+        </p:spPr>
+        <p:txBody>
+          <a:bodyPr wrap="square" lIns="0" tIns="0" rIns="0" bIns="0" rtlCol="0" anchor="ctr"/>
+          <a:lstStyle/>
+          <a:p>
+            <a:pPr indent="0" marL="0">
+              <a:buNone/>
+            </a:pPr>
+            <a:r>
+              <a:rPr lang="en-US" sz="3200" b="1" dirty="0">
+                <a:solidFill>
+                  <a:srgbClr val="17313B"/>
+                </a:solidFill>
+                <a:latin typeface="Malgun Gothic" pitchFamily="34" charset="0"/>
+                <a:ea typeface="Malgun Gothic" pitchFamily="34" charset="-122"/>
+                <a:cs typeface="Malgun Gothic" pitchFamily="34" charset="-120"/>
+              </a:rPr>
+              <a:t>제품·기술 축 — FDP Host–SSD 통합 플랫폼</a:t>
+            </a:r>
+            <a:endParaRPr lang="en-US" sz="3200" dirty="0"/>
+          </a:p>
+        </p:txBody>
+      </p:sp>
+      <p:sp>
+        <p:nvSpPr>
+          <p:cNvPr id="3" name="Text 1"/>
+          <p:cNvSpPr/>
+          <p:nvPr/>
+        </p:nvSpPr>
+        <p:spPr>
+          <a:xfrm>
+            <a:off x="10268712" y="310896"/>
+            <a:ext cx="1463040" cy="420624"/>
+          </a:xfrm>
+          <a:prstGeom prst="roundRect">
+            <a:avLst>
+              <a:gd name="adj" fmla="val 21739"/>
+            </a:avLst>
+          </a:prstGeom>
+          <a:solidFill>
+            <a:srgbClr val="EFF3F5"/>
+          </a:solidFill>
+          <a:ln/>
+        </p:spPr>
+        <p:txBody>
+          <a:bodyPr wrap="square" lIns="0" tIns="0" rIns="0" bIns="0" rtlCol="0" anchor="ctr"/>
+          <a:lstStyle/>
+          <a:p>
+            <a:pPr algn="ctr" indent="0" marL="0">
+              <a:buNone/>
+            </a:pPr>
+            <a:r>
+              <a:rPr lang="en-US" sz="1400" b="1" dirty="0">
+                <a:solidFill>
+                  <a:srgbClr val="5A7184"/>
+                </a:solidFill>
+                <a:latin typeface="Malgun Gothic" pitchFamily="34" charset="0"/>
+                <a:ea typeface="Malgun Gothic" pitchFamily="34" charset="-122"/>
+                <a:cs typeface="Malgun Gothic" pitchFamily="34" charset="-120"/>
+              </a:rPr>
+              <a:t>제품 축 ①</a:t>
+            </a:r>
+            <a:endParaRPr lang="en-US" sz="1400" dirty="0"/>
+          </a:p>
+        </p:txBody>
+      </p:sp>
+      <p:sp>
+        <p:nvSpPr>
+          <p:cNvPr id="4" name="Text 2"/>
+          <p:cNvSpPr/>
+          <p:nvPr/>
+        </p:nvSpPr>
+        <p:spPr>
+          <a:xfrm>
+            <a:off x="457200" y="6510528"/>
+            <a:ext cx="6949440" cy="256032"/>
+          </a:xfrm>
+          <a:prstGeom prst="rect">
+            <a:avLst/>
+          </a:prstGeom>
+          <a:noFill/>
+          <a:ln/>
+        </p:spPr>
+        <p:txBody>
+          <a:bodyPr wrap="square" lIns="0" tIns="0" rIns="0" bIns="0" rtlCol="0" anchor="ctr"/>
+          <a:lstStyle/>
+          <a:p>
+            <a:pPr indent="0" marL="0">
+              <a:buNone/>
+            </a:pPr>
+            <a:r>
+              <a:rPr lang="en-US" sz="1000" dirty="0">
+                <a:solidFill>
+                  <a:srgbClr val="5A7184"/>
+                </a:solidFill>
+                <a:latin typeface="Malgun Gothic" pitchFamily="34" charset="0"/>
+                <a:ea typeface="Malgun Gothic" pitchFamily="34" charset="-122"/>
+                <a:cs typeface="Malgun Gothic" pitchFamily="34" charset="-120"/>
+              </a:rPr>
+              <a:t>삼성전자 메모리사업부 · 개발실 체질 전환 전략 요약 · 2026-07-24</a:t>
+            </a:r>
+            <a:endParaRPr lang="en-US" sz="1000" dirty="0"/>
+          </a:p>
+        </p:txBody>
+      </p:sp>
+      <p:sp>
+        <p:nvSpPr>
+          <p:cNvPr id="5" name="Text 3"/>
+          <p:cNvSpPr/>
+          <p:nvPr/>
+        </p:nvSpPr>
+        <p:spPr>
+          <a:xfrm>
+            <a:off x="7589520" y="6510528"/>
+            <a:ext cx="4142232" cy="256032"/>
+          </a:xfrm>
+          <a:prstGeom prst="rect">
+            <a:avLst/>
+          </a:prstGeom>
+          <a:noFill/>
+          <a:ln/>
+        </p:spPr>
+        <p:txBody>
+          <a:bodyPr wrap="square" lIns="0" tIns="0" rIns="0" bIns="0" rtlCol="0" anchor="ctr"/>
+          <a:lstStyle/>
+          <a:p>
+            <a:pPr algn="r" indent="0" marL="0">
+              <a:buNone/>
+            </a:pPr>
+            <a:r>
+              <a:rPr lang="en-US" sz="1000" dirty="0">
+                <a:solidFill>
+                  <a:srgbClr val="5A7184"/>
+                </a:solidFill>
+                <a:latin typeface="Malgun Gothic" pitchFamily="34" charset="0"/>
+                <a:ea typeface="Malgun Gothic" pitchFamily="34" charset="-122"/>
+                <a:cs typeface="Malgun Gothic" pitchFamily="34" charset="-120"/>
+              </a:rPr>
+              <a:t>원천: wiki/strategies/fdp-host-ssd-platform.md</a:t>
+            </a:r>
+            <a:endParaRPr lang="en-US" sz="1000" dirty="0"/>
+          </a:p>
+        </p:txBody>
+      </p:sp>
+      <p:sp>
+        <p:nvSpPr>
+          <p:cNvPr id="6" name="Text 4"/>
+          <p:cNvSpPr/>
+          <p:nvPr/>
+        </p:nvSpPr>
+        <p:spPr>
+          <a:xfrm>
+            <a:off x="457200" y="859536"/>
+            <a:ext cx="11274552" cy="512064"/>
+          </a:xfrm>
+          <a:prstGeom prst="roundRect">
+            <a:avLst>
+              <a:gd name="adj" fmla="val 16071"/>
+            </a:avLst>
+          </a:prstGeom>
+          <a:solidFill>
+            <a:srgbClr val="F5F7F8"/>
+          </a:solidFill>
+          <a:ln/>
+        </p:spPr>
+        <p:txBody>
+          <a:bodyPr wrap="square" lIns="0" tIns="0" rIns="0" bIns="0" rtlCol="0" anchor="ctr"/>
+          <a:lstStyle/>
+          <a:p>
+            <a:pPr algn="ctr" indent="0" marL="0">
+              <a:buNone/>
+            </a:pPr>
+            <a:r>
+              <a:rPr lang="en-US" sz="1650" i="1" dirty="0">
+                <a:solidFill>
+                  <a:srgbClr val="17313B"/>
+                </a:solidFill>
+                <a:latin typeface="Malgun Gothic" pitchFamily="34" charset="0"/>
+                <a:ea typeface="Malgun Gothic" pitchFamily="34" charset="-122"/>
+                <a:cs typeface="Malgun Gothic" pitchFamily="34" charset="-120"/>
+              </a:rPr>
+              <a:t>“Binding으로 수요를 확보하고, FDP로 제품을 표준화하며, 시스템 소프트웨어로 고객 워크로드를 연결한다”</a:t>
+            </a:r>
+            <a:endParaRPr lang="en-US" sz="1650" dirty="0"/>
+          </a:p>
+        </p:txBody>
+      </p:sp>
+      <p:sp>
+        <p:nvSpPr>
+          <p:cNvPr id="7" name="Shape 5"/>
+          <p:cNvSpPr/>
+          <p:nvPr/>
+        </p:nvSpPr>
+        <p:spPr>
+          <a:xfrm>
+            <a:off x="2011680" y="1517904"/>
+            <a:ext cx="3200400" cy="1371600"/>
+          </a:xfrm>
+          <a:prstGeom prst="roundRect">
+            <a:avLst>
+              <a:gd name="adj" fmla="val 6667"/>
+            </a:avLst>
+          </a:prstGeom>
+          <a:solidFill>
+            <a:srgbClr val="F5F7F8"/>
+          </a:solidFill>
+          <a:ln w="15875">
+            <a:solidFill>
+              <a:srgbClr val="DCE4E9"/>
+            </a:solidFill>
+            <a:prstDash val="solid"/>
+          </a:ln>
+        </p:spPr>
+      </p:sp>
+      <p:sp>
+        <p:nvSpPr>
+          <p:cNvPr id="8" name="Shape 6"/>
+          <p:cNvSpPr/>
+          <p:nvPr/>
+        </p:nvSpPr>
+        <p:spPr>
+          <a:xfrm>
+            <a:off x="3401568" y="1645920"/>
+            <a:ext cx="420624" cy="420624"/>
+          </a:xfrm>
+          <a:prstGeom prst="ellipse">
+            <a:avLst/>
+          </a:prstGeom>
+          <a:solidFill>
+            <a:srgbClr val="5A7184"/>
+          </a:solidFill>
+          <a:ln/>
+        </p:spPr>
+      </p:sp>
+      <p:pic>
+        <p:nvPicPr>
+          <p:cNvPr id="9" name="Image 0" descr="preencoded.png">    </p:cNvPr>
+          <p:cNvPicPr>
+            <a:picLocks noChangeAspect="1"/>
+          </p:cNvPicPr>
+          <p:nvPr/>
+        </p:nvPicPr>
+        <p:blipFill>
+          <a:blip r:embed="rId1"/>
+          <a:stretch>
+            <a:fillRect/>
+          </a:stretch>
+        </p:blipFill>
+        <p:spPr>
+          <a:xfrm>
+            <a:off x="3502518" y="1746870"/>
+            <a:ext cx="218724" cy="218724"/>
+          </a:xfrm>
+          <a:prstGeom prst="rect">
+            <a:avLst/>
+          </a:prstGeom>
+        </p:spPr>
+      </p:pic>
+      <p:sp>
+        <p:nvSpPr>
+          <p:cNvPr id="10" name="Text 7"/>
+          <p:cNvSpPr/>
+          <p:nvPr/>
+        </p:nvSpPr>
+        <p:spPr>
+          <a:xfrm>
+            <a:off x="2103120" y="2103120"/>
+            <a:ext cx="3017520" cy="329184"/>
+          </a:xfrm>
+          <a:prstGeom prst="rect">
+            <a:avLst/>
+          </a:prstGeom>
+          <a:noFill/>
+          <a:ln/>
+        </p:spPr>
+        <p:txBody>
+          <a:bodyPr wrap="square" lIns="0" tIns="0" rIns="0" bIns="0" rtlCol="0" anchor="ctr"/>
+          <a:lstStyle/>
+          <a:p>
+            <a:pPr algn="ctr" indent="0" marL="0">
+              <a:buNone/>
+            </a:pPr>
+            <a:r>
+              <a:rPr lang="en-US" sz="1900" b="1" dirty="0">
+                <a:solidFill>
+                  <a:srgbClr val="5A7184"/>
+                </a:solidFill>
+                <a:latin typeface="Malgun Gothic" pitchFamily="34" charset="0"/>
+                <a:ea typeface="Malgun Gothic" pitchFamily="34" charset="-122"/>
+                <a:cs typeface="Malgun Gothic" pitchFamily="34" charset="-120"/>
+              </a:rPr>
+              <a:t>FDP SSD 공급자</a:t>
+            </a:r>
+            <a:endParaRPr lang="en-US" sz="1900" dirty="0"/>
+          </a:p>
+        </p:txBody>
+      </p:sp>
+      <p:sp>
+        <p:nvSpPr>
+          <p:cNvPr id="11" name="Text 8"/>
+          <p:cNvSpPr/>
+          <p:nvPr/>
+        </p:nvSpPr>
+        <p:spPr>
+          <a:xfrm>
+            <a:off x="2103120" y="2468880"/>
+            <a:ext cx="3017520" cy="256032"/>
+          </a:xfrm>
+          <a:prstGeom prst="rect">
+            <a:avLst/>
+          </a:prstGeom>
+          <a:noFill/>
+          <a:ln/>
+        </p:spPr>
+        <p:txBody>
+          <a:bodyPr wrap="square" lIns="0" tIns="0" rIns="0" bIns="0" rtlCol="0" anchor="ctr"/>
+          <a:lstStyle/>
+          <a:p>
+            <a:pPr algn="ctr" indent="0" marL="0">
+              <a:buNone/>
+            </a:pPr>
+            <a:r>
+              <a:rPr lang="en-US" sz="1150" dirty="0">
+                <a:solidFill>
+                  <a:srgbClr val="5A7184"/>
+                </a:solidFill>
+                <a:latin typeface="Malgun Gothic" pitchFamily="34" charset="0"/>
+                <a:ea typeface="Malgun Gothic" pitchFamily="34" charset="-122"/>
+                <a:cs typeface="Malgun Gothic" pitchFamily="34" charset="-120"/>
+              </a:rPr>
+              <a:t>여러 공급사 중 하나 · 가격 경쟁 노출</a:t>
+            </a:r>
+            <a:endParaRPr lang="en-US" sz="1150" dirty="0"/>
+          </a:p>
+        </p:txBody>
+      </p:sp>
+      <p:sp>
+        <p:nvSpPr>
+          <p:cNvPr id="12" name="Text 9"/>
+          <p:cNvSpPr/>
+          <p:nvPr/>
+        </p:nvSpPr>
+        <p:spPr>
+          <a:xfrm>
+            <a:off x="5285232" y="1792224"/>
+            <a:ext cx="1591056" cy="822960"/>
+          </a:xfrm>
+          <a:prstGeom prst="rightArrow">
+            <a:avLst/>
+          </a:prstGeom>
+          <a:solidFill>
+            <a:srgbClr val="028090"/>
+          </a:solidFill>
+          <a:ln/>
+        </p:spPr>
+        <p:txBody>
+          <a:bodyPr wrap="square" lIns="0" tIns="0" rIns="0" bIns="0" rtlCol="0" anchor="ctr"/>
+          <a:lstStyle/>
+          <a:p>
+            <a:pPr algn="ctr" indent="0" marL="0">
+              <a:buNone/>
+            </a:pPr>
+            <a:r>
+              <a:rPr lang="en-US" sz="1200" b="1" dirty="0">
+                <a:solidFill>
+                  <a:srgbClr val="FFFFFF"/>
+                </a:solidFill>
+                <a:latin typeface="Malgun Gothic" pitchFamily="34" charset="0"/>
+                <a:ea typeface="Malgun Gothic" pitchFamily="34" charset="-122"/>
+                <a:cs typeface="Malgun Gothic" pitchFamily="34" charset="-120"/>
+              </a:rPr>
+              <a:t>+ 시스템 SW</a:t>
+            </a:r>
+            <a:endParaRPr lang="en-US" sz="1200" dirty="0"/>
+          </a:p>
+        </p:txBody>
+      </p:sp>
+      <p:sp>
+        <p:nvSpPr>
+          <p:cNvPr id="13" name="Shape 10"/>
+          <p:cNvSpPr/>
+          <p:nvPr/>
+        </p:nvSpPr>
+        <p:spPr>
+          <a:xfrm>
+            <a:off x="6949440" y="1517904"/>
+            <a:ext cx="3200400" cy="1371600"/>
+          </a:xfrm>
+          <a:prstGeom prst="roundRect">
+            <a:avLst>
+              <a:gd name="adj" fmla="val 6667"/>
+            </a:avLst>
+          </a:prstGeom>
+          <a:solidFill>
+            <a:srgbClr val="E8F6F0"/>
+          </a:solidFill>
+          <a:ln w="19050">
+            <a:solidFill>
+              <a:srgbClr val="02A878"/>
+            </a:solidFill>
+            <a:prstDash val="solid"/>
+          </a:ln>
+        </p:spPr>
+      </p:sp>
+      <p:sp>
+        <p:nvSpPr>
+          <p:cNvPr id="14" name="Shape 11"/>
+          <p:cNvSpPr/>
+          <p:nvPr/>
+        </p:nvSpPr>
+        <p:spPr>
+          <a:xfrm>
+            <a:off x="8339328" y="1645920"/>
+            <a:ext cx="420624" cy="420624"/>
+          </a:xfrm>
+          <a:prstGeom prst="ellipse">
+            <a:avLst/>
+          </a:prstGeom>
+          <a:solidFill>
+            <a:srgbClr val="02A878"/>
+          </a:solidFill>
+          <a:ln/>
+        </p:spPr>
+      </p:sp>
+      <p:pic>
+        <p:nvPicPr>
+          <p:cNvPr id="15" name="Image 1" descr="preencoded.png">    </p:cNvPr>
+          <p:cNvPicPr>
+            <a:picLocks noChangeAspect="1"/>
+          </p:cNvPicPr>
+          <p:nvPr/>
+        </p:nvPicPr>
+        <p:blipFill>
+          <a:blip r:embed="rId2"/>
+          <a:stretch>
+            <a:fillRect/>
+          </a:stretch>
+        </p:blipFill>
+        <p:spPr>
+          <a:xfrm>
+            <a:off x="8440278" y="1746870"/>
+            <a:ext cx="218724" cy="218724"/>
+          </a:xfrm>
+          <a:prstGeom prst="rect">
+            <a:avLst/>
+          </a:prstGeom>
+        </p:spPr>
+      </p:pic>
+      <p:sp>
+        <p:nvSpPr>
+          <p:cNvPr id="16" name="Text 12"/>
+          <p:cNvSpPr/>
+          <p:nvPr/>
+        </p:nvSpPr>
+        <p:spPr>
+          <a:xfrm>
+            <a:off x="7040880" y="2103120"/>
+            <a:ext cx="3017520" cy="329184"/>
+          </a:xfrm>
+          <a:prstGeom prst="rect">
+            <a:avLst/>
+          </a:prstGeom>
+          <a:noFill/>
+          <a:ln/>
+        </p:spPr>
+        <p:txBody>
+          <a:bodyPr wrap="square" lIns="0" tIns="0" rIns="0" bIns="0" rtlCol="0" anchor="ctr"/>
+          <a:lstStyle/>
+          <a:p>
+            <a:pPr algn="ctr" indent="0" marL="0">
+              <a:buNone/>
+            </a:pPr>
+            <a:r>
+              <a:rPr lang="en-US" sz="1900" b="1" dirty="0">
+                <a:solidFill>
+                  <a:srgbClr val="02A878"/>
+                </a:solidFill>
+                <a:latin typeface="Malgun Gothic" pitchFamily="34" charset="0"/>
+                <a:ea typeface="Malgun Gothic" pitchFamily="34" charset="-122"/>
+                <a:cs typeface="Malgun Gothic" pitchFamily="34" charset="-120"/>
+              </a:rPr>
+              <a:t>통합 솔루션 제공자</a:t>
+            </a:r>
+            <a:endParaRPr lang="en-US" sz="1900" dirty="0"/>
+          </a:p>
+        </p:txBody>
+      </p:sp>
+      <p:sp>
+        <p:nvSpPr>
+          <p:cNvPr id="17" name="Text 13"/>
+          <p:cNvSpPr/>
+          <p:nvPr/>
+        </p:nvSpPr>
+        <p:spPr>
+          <a:xfrm>
+            <a:off x="6949440" y="2468880"/>
+            <a:ext cx="3200400" cy="256032"/>
+          </a:xfrm>
+          <a:prstGeom prst="rect">
+            <a:avLst/>
+          </a:prstGeom>
+          <a:noFill/>
+          <a:ln/>
+        </p:spPr>
+        <p:txBody>
+          <a:bodyPr wrap="square" lIns="0" tIns="0" rIns="0" bIns="0" rtlCol="0" anchor="ctr"/>
+          <a:lstStyle/>
+          <a:p>
+            <a:pPr algn="ctr" indent="0" marL="0">
+              <a:buNone/>
+            </a:pPr>
+            <a:r>
+              <a:rPr lang="en-US" sz="1150" dirty="0">
+                <a:solidFill>
+                  <a:srgbClr val="17313B"/>
+                </a:solidFill>
+                <a:latin typeface="Malgun Gothic" pitchFamily="34" charset="0"/>
+                <a:ea typeface="Malgun Gothic" pitchFamily="34" charset="-122"/>
+                <a:cs typeface="Malgun Gothic" pitchFamily="34" charset="-120"/>
+              </a:rPr>
+              <a:t>Host SDK · Profiler · End-to-End 검증</a:t>
+            </a:r>
+            <a:endParaRPr lang="en-US" sz="1150" dirty="0"/>
+          </a:p>
+        </p:txBody>
+      </p:sp>
+      <p:sp>
+        <p:nvSpPr>
+          <p:cNvPr id="18" name="Text 14"/>
+          <p:cNvSpPr/>
+          <p:nvPr/>
+        </p:nvSpPr>
+        <p:spPr>
+          <a:xfrm>
+            <a:off x="457200" y="3035808"/>
+            <a:ext cx="5486400" cy="256032"/>
+          </a:xfrm>
+          <a:prstGeom prst="rect">
+            <a:avLst/>
+          </a:prstGeom>
+          <a:noFill/>
+          <a:ln/>
+        </p:spPr>
+        <p:txBody>
+          <a:bodyPr wrap="square" lIns="0" tIns="0" rIns="0" bIns="0" rtlCol="0" anchor="ctr"/>
+          <a:lstStyle/>
+          <a:p>
+            <a:pPr indent="0" marL="0">
+              <a:buNone/>
+            </a:pPr>
+            <a:r>
+              <a:rPr lang="en-US" sz="1400" b="1" dirty="0">
+                <a:solidFill>
+                  <a:srgbClr val="17313B"/>
+                </a:solidFill>
+                <a:latin typeface="Malgun Gothic" pitchFamily="34" charset="0"/>
+                <a:ea typeface="Malgun Gothic" pitchFamily="34" charset="-122"/>
+                <a:cs typeface="Malgun Gothic" pitchFamily="34" charset="-120"/>
+              </a:rPr>
+              <a:t>왜 시스템 소프트웨어인가</a:t>
+            </a:r>
+            <a:endParaRPr lang="en-US" sz="1400" dirty="0"/>
+          </a:p>
+        </p:txBody>
+      </p:sp>
+      <p:sp>
+        <p:nvSpPr>
+          <p:cNvPr id="19" name="Text 15"/>
+          <p:cNvSpPr/>
+          <p:nvPr/>
+        </p:nvSpPr>
+        <p:spPr>
+          <a:xfrm>
+            <a:off x="457200" y="3328416"/>
+            <a:ext cx="3602736" cy="877824"/>
+          </a:xfrm>
+          <a:prstGeom prst="roundRect">
+            <a:avLst>
+              <a:gd name="adj" fmla="val 8333"/>
+            </a:avLst>
+          </a:prstGeom>
+          <a:solidFill>
+            <a:srgbClr val="F5F7F8"/>
+          </a:solidFill>
+          <a:ln/>
+        </p:spPr>
+        <p:txBody>
+          <a:bodyPr wrap="square" lIns="0" tIns="0" rIns="0" bIns="0" rtlCol="0" anchor="ctr"/>
+          <a:lstStyle/>
+          <a:p>
+            <a:pPr algn="ctr" indent="0" marL="0">
+              <a:lnSpc>
+                <a:spcPct val="110000"/>
+              </a:lnSpc>
+              <a:buNone/>
+            </a:pPr>
+            <a:r>
+              <a:rPr lang="en-US" sz="1350" b="1" dirty="0">
+                <a:solidFill>
+                  <a:srgbClr val="17313B"/>
+                </a:solidFill>
+                <a:latin typeface="Malgun Gothic" pitchFamily="34" charset="0"/>
+                <a:ea typeface="Malgun Gothic" pitchFamily="34" charset="-122"/>
+                <a:cs typeface="Malgun Gothic" pitchFamily="34" charset="-120"/>
+              </a:rPr>
+              <a:t>FDP는 인터페이스일 뿐</a:t>
+            </a:r>
+            <a:endParaRPr lang="en-US" sz="1350" dirty="0"/>
+          </a:p>
+          <a:p>
+            <a:pPr algn="ctr" indent="0" marL="0">
+              <a:lnSpc>
+                <a:spcPct val="110000"/>
+              </a:lnSpc>
+              <a:buNone/>
+            </a:pPr>
+            <a:r>
+              <a:rPr lang="en-US" sz="1050" dirty="0">
+                <a:solidFill>
+                  <a:srgbClr val="5A7184"/>
+                </a:solidFill>
+                <a:latin typeface="Malgun Gothic" pitchFamily="34" charset="0"/>
+                <a:ea typeface="Malgun Gothic" pitchFamily="34" charset="-122"/>
+                <a:cs typeface="Malgun Gothic" pitchFamily="34" charset="-120"/>
+              </a:rPr>
+              <a:t>SSD는 hot/cold·수명·테넌트를 모른다 — 정보는 DB·캐시 등 상위 SW에 있다</a:t>
+            </a:r>
+            <a:endParaRPr lang="en-US" sz="1350" dirty="0"/>
+          </a:p>
+        </p:txBody>
+      </p:sp>
+      <p:sp>
+        <p:nvSpPr>
+          <p:cNvPr id="20" name="Text 16"/>
+          <p:cNvSpPr/>
+          <p:nvPr/>
+        </p:nvSpPr>
+        <p:spPr>
+          <a:xfrm>
+            <a:off x="4297680" y="3328416"/>
+            <a:ext cx="3602736" cy="877824"/>
+          </a:xfrm>
+          <a:prstGeom prst="roundRect">
+            <a:avLst>
+              <a:gd name="adj" fmla="val 8333"/>
+            </a:avLst>
+          </a:prstGeom>
+          <a:solidFill>
+            <a:srgbClr val="F5F7F8"/>
+          </a:solidFill>
+          <a:ln/>
+        </p:spPr>
+        <p:txBody>
+          <a:bodyPr wrap="square" lIns="0" tIns="0" rIns="0" bIns="0" rtlCol="0" anchor="ctr"/>
+          <a:lstStyle/>
+          <a:p>
+            <a:pPr algn="ctr" indent="0" marL="0">
+              <a:lnSpc>
+                <a:spcPct val="110000"/>
+              </a:lnSpc>
+              <a:buNone/>
+            </a:pPr>
+            <a:r>
+              <a:rPr lang="en-US" sz="1350" b="1" dirty="0">
+                <a:solidFill>
+                  <a:srgbClr val="17313B"/>
+                </a:solidFill>
+                <a:latin typeface="Malgun Gothic" pitchFamily="34" charset="0"/>
+                <a:ea typeface="Malgun Gothic" pitchFamily="34" charset="-122"/>
+                <a:cs typeface="Malgun Gothic" pitchFamily="34" charset="-120"/>
+              </a:rPr>
+              <a:t>Captive SSD 확대</a:t>
+            </a:r>
+            <a:endParaRPr lang="en-US" sz="1350" dirty="0"/>
+          </a:p>
+          <a:p>
+            <a:pPr algn="ctr" indent="0" marL="0">
+              <a:lnSpc>
+                <a:spcPct val="110000"/>
+              </a:lnSpc>
+              <a:buNone/>
+            </a:pPr>
+            <a:r>
+              <a:rPr lang="en-US" sz="1050" dirty="0">
+                <a:solidFill>
+                  <a:srgbClr val="5A7184"/>
+                </a:solidFill>
+                <a:latin typeface="Malgun Gothic" pitchFamily="34" charset="0"/>
+                <a:ea typeface="Malgun Gothic" pitchFamily="34" charset="-122"/>
+                <a:cs typeface="Malgun Gothic" pitchFamily="34" charset="-120"/>
+              </a:rPr>
+              <a:t>NAND 공급에만 머물면 완제품 SSD의 부가가치를 잃는다</a:t>
+            </a:r>
+            <a:endParaRPr lang="en-US" sz="1350" dirty="0"/>
+          </a:p>
+        </p:txBody>
+      </p:sp>
+      <p:sp>
+        <p:nvSpPr>
+          <p:cNvPr id="21" name="Text 17"/>
+          <p:cNvSpPr/>
+          <p:nvPr/>
+        </p:nvSpPr>
+        <p:spPr>
+          <a:xfrm>
+            <a:off x="8138160" y="3328416"/>
+            <a:ext cx="3602736" cy="877824"/>
+          </a:xfrm>
+          <a:prstGeom prst="roundRect">
+            <a:avLst>
+              <a:gd name="adj" fmla="val 8333"/>
+            </a:avLst>
+          </a:prstGeom>
+          <a:solidFill>
+            <a:srgbClr val="F5F7F8"/>
+          </a:solidFill>
+          <a:ln/>
+        </p:spPr>
+        <p:txBody>
+          <a:bodyPr wrap="square" lIns="0" tIns="0" rIns="0" bIns="0" rtlCol="0" anchor="ctr"/>
+          <a:lstStyle/>
+          <a:p>
+            <a:pPr algn="ctr" indent="0" marL="0">
+              <a:lnSpc>
+                <a:spcPct val="110000"/>
+              </a:lnSpc>
+              <a:buNone/>
+            </a:pPr>
+            <a:r>
+              <a:rPr lang="en-US" sz="1350" b="1" dirty="0">
+                <a:solidFill>
+                  <a:srgbClr val="17313B"/>
+                </a:solidFill>
+                <a:latin typeface="Malgun Gothic" pitchFamily="34" charset="0"/>
+                <a:ea typeface="Malgun Gothic" pitchFamily="34" charset="-122"/>
+                <a:cs typeface="Malgun Gothic" pitchFamily="34" charset="-120"/>
+              </a:rPr>
+              <a:t>커스텀 파편화</a:t>
+            </a:r>
+            <a:endParaRPr lang="en-US" sz="1350" dirty="0"/>
+          </a:p>
+          <a:p>
+            <a:pPr algn="ctr" indent="0" marL="0">
+              <a:lnSpc>
+                <a:spcPct val="110000"/>
+              </a:lnSpc>
+              <a:buNone/>
+            </a:pPr>
+            <a:r>
+              <a:rPr lang="en-US" sz="1050" dirty="0">
+                <a:solidFill>
+                  <a:srgbClr val="5A7184"/>
+                </a:solidFill>
+                <a:latin typeface="Malgun Gothic" pitchFamily="34" charset="0"/>
+                <a:ea typeface="Malgun Gothic" pitchFamily="34" charset="-122"/>
+                <a:cs typeface="Malgun Gothic" pitchFamily="34" charset="-120"/>
+              </a:rPr>
+              <a:t>고객별 커스텀 SSD 개발은 제품·펌웨어를 파편화시킨다</a:t>
+            </a:r>
+            <a:endParaRPr lang="en-US" sz="1350" dirty="0"/>
+          </a:p>
+        </p:txBody>
+      </p:sp>
+      <p:sp>
+        <p:nvSpPr>
+          <p:cNvPr id="22" name="Text 18"/>
+          <p:cNvSpPr/>
+          <p:nvPr/>
+        </p:nvSpPr>
+        <p:spPr>
+          <a:xfrm>
+            <a:off x="457200" y="4425696"/>
+            <a:ext cx="5486400" cy="256032"/>
+          </a:xfrm>
+          <a:prstGeom prst="rect">
+            <a:avLst/>
+          </a:prstGeom>
+          <a:noFill/>
+          <a:ln/>
+        </p:spPr>
+        <p:txBody>
+          <a:bodyPr wrap="square" lIns="0" tIns="0" rIns="0" bIns="0" rtlCol="0" anchor="ctr"/>
+          <a:lstStyle/>
+          <a:p>
+            <a:pPr indent="0" marL="0">
+              <a:buNone/>
+            </a:pPr>
+            <a:r>
+              <a:rPr lang="en-US" sz="1400" b="1" dirty="0">
+                <a:solidFill>
+                  <a:srgbClr val="17313B"/>
+                </a:solidFill>
+                <a:latin typeface="Malgun Gothic" pitchFamily="34" charset="0"/>
+                <a:ea typeface="Malgun Gothic" pitchFamily="34" charset="-122"/>
+                <a:cs typeface="Malgun Gothic" pitchFamily="34" charset="-120"/>
+              </a:rPr>
+              <a:t>전체 전략 구조 — 6요소</a:t>
+            </a:r>
+            <a:endParaRPr lang="en-US" sz="1400" dirty="0"/>
+          </a:p>
+        </p:txBody>
+      </p:sp>
+      <p:sp>
+        <p:nvSpPr>
+          <p:cNvPr id="23" name="Text 19"/>
+          <p:cNvSpPr/>
+          <p:nvPr/>
+        </p:nvSpPr>
+        <p:spPr>
+          <a:xfrm>
+            <a:off x="457200" y="4718304"/>
+            <a:ext cx="1682496" cy="731520"/>
+          </a:xfrm>
+          <a:prstGeom prst="roundRect">
+            <a:avLst>
+              <a:gd name="adj" fmla="val 8750"/>
+            </a:avLst>
+          </a:prstGeom>
+          <a:solidFill>
+            <a:srgbClr val="FFFFFF"/>
+          </a:solidFill>
+          <a:ln w="12700">
+            <a:solidFill>
+              <a:srgbClr val="DCE4E9"/>
+            </a:solidFill>
+          </a:ln>
+        </p:spPr>
+        <p:txBody>
+          <a:bodyPr wrap="square" lIns="0" tIns="0" rIns="0" bIns="0" rtlCol="0" anchor="ctr"/>
+          <a:lstStyle/>
+          <a:p>
+            <a:pPr algn="ctr" indent="0" marL="0">
+              <a:lnSpc>
+                <a:spcPct val="105000"/>
+              </a:lnSpc>
+              <a:buNone/>
+            </a:pPr>
+            <a:r>
+              <a:rPr lang="en-US" sz="1200" b="1" dirty="0">
+                <a:solidFill>
+                  <a:srgbClr val="17313B"/>
+                </a:solidFill>
+                <a:latin typeface="Malgun Gothic" pitchFamily="34" charset="0"/>
+                <a:ea typeface="Malgun Gothic" pitchFamily="34" charset="-122"/>
+                <a:cs typeface="Malgun Gothic" pitchFamily="34" charset="-120"/>
+              </a:rPr>
+              <a:t>Binding 계약</a:t>
+            </a:r>
+            <a:endParaRPr lang="en-US" sz="1200" dirty="0"/>
+          </a:p>
+          <a:p>
+            <a:pPr algn="ctr" indent="0" marL="0">
+              <a:lnSpc>
+                <a:spcPct val="105000"/>
+              </a:lnSpc>
+              <a:buNone/>
+            </a:pPr>
+            <a:r>
+              <a:rPr lang="en-US" sz="950" dirty="0">
+                <a:solidFill>
+                  <a:srgbClr val="5A7184"/>
+                </a:solidFill>
+                <a:latin typeface="Malgun Gothic" pitchFamily="34" charset="0"/>
+                <a:ea typeface="Malgun Gothic" pitchFamily="34" charset="-122"/>
+                <a:cs typeface="Malgun Gothic" pitchFamily="34" charset="-120"/>
+              </a:rPr>
+              <a:t>장기 물량 확보</a:t>
+            </a:r>
+            <a:endParaRPr lang="en-US" sz="1200" dirty="0"/>
+          </a:p>
+        </p:txBody>
+      </p:sp>
+      <p:sp>
+        <p:nvSpPr>
+          <p:cNvPr id="24" name="Text 20"/>
+          <p:cNvSpPr/>
+          <p:nvPr/>
+        </p:nvSpPr>
+        <p:spPr>
+          <a:xfrm>
+            <a:off x="2139696" y="4718304"/>
+            <a:ext cx="201168" cy="731520"/>
+          </a:xfrm>
+          <a:prstGeom prst="rect">
+            <a:avLst/>
+          </a:prstGeom>
+          <a:noFill/>
+          <a:ln/>
+        </p:spPr>
+        <p:txBody>
+          <a:bodyPr wrap="square" lIns="0" tIns="0" rIns="0" bIns="0" rtlCol="0" anchor="ctr"/>
+          <a:lstStyle/>
+          <a:p>
+            <a:pPr algn="ctr" indent="0" marL="0">
+              <a:buNone/>
+            </a:pPr>
+            <a:r>
+              <a:rPr lang="en-US" sz="1050" dirty="0">
+                <a:solidFill>
+                  <a:srgbClr val="5A7184"/>
+                </a:solidFill>
+                <a:latin typeface="Malgun Gothic" pitchFamily="34" charset="0"/>
+                <a:ea typeface="Malgun Gothic" pitchFamily="34" charset="-122"/>
+                <a:cs typeface="Malgun Gothic" pitchFamily="34" charset="-120"/>
+              </a:rPr>
+              <a:t>▶</a:t>
+            </a:r>
+            <a:endParaRPr lang="en-US" sz="1050" dirty="0"/>
+          </a:p>
+        </p:txBody>
+      </p:sp>
+      <p:sp>
+        <p:nvSpPr>
+          <p:cNvPr id="25" name="Text 21"/>
+          <p:cNvSpPr/>
+          <p:nvPr/>
+        </p:nvSpPr>
+        <p:spPr>
+          <a:xfrm>
+            <a:off x="2340864" y="4718304"/>
+            <a:ext cx="1682496" cy="731520"/>
+          </a:xfrm>
+          <a:prstGeom prst="roundRect">
+            <a:avLst>
+              <a:gd name="adj" fmla="val 8750"/>
+            </a:avLst>
+          </a:prstGeom>
+          <a:solidFill>
+            <a:srgbClr val="FFFFFF"/>
+          </a:solidFill>
+          <a:ln w="12700">
+            <a:solidFill>
+              <a:srgbClr val="DCE4E9"/>
+            </a:solidFill>
+          </a:ln>
+        </p:spPr>
+        <p:txBody>
+          <a:bodyPr wrap="square" lIns="0" tIns="0" rIns="0" bIns="0" rtlCol="0" anchor="ctr"/>
+          <a:lstStyle/>
+          <a:p>
+            <a:pPr algn="ctr" indent="0" marL="0">
+              <a:lnSpc>
+                <a:spcPct val="105000"/>
+              </a:lnSpc>
+              <a:buNone/>
+            </a:pPr>
+            <a:r>
+              <a:rPr lang="en-US" sz="1200" b="1" dirty="0">
+                <a:solidFill>
+                  <a:srgbClr val="17313B"/>
+                </a:solidFill>
+                <a:latin typeface="Malgun Gothic" pitchFamily="34" charset="0"/>
+                <a:ea typeface="Malgun Gothic" pitchFamily="34" charset="-122"/>
+                <a:cs typeface="Malgun Gothic" pitchFamily="34" charset="-120"/>
+              </a:rPr>
+              <a:t>FDP 표준 SSD</a:t>
+            </a:r>
+            <a:endParaRPr lang="en-US" sz="1200" dirty="0"/>
+          </a:p>
+          <a:p>
+            <a:pPr algn="ctr" indent="0" marL="0">
+              <a:lnSpc>
+                <a:spcPct val="105000"/>
+              </a:lnSpc>
+              <a:buNone/>
+            </a:pPr>
+            <a:r>
+              <a:rPr lang="en-US" sz="950" dirty="0">
+                <a:solidFill>
+                  <a:srgbClr val="5A7184"/>
+                </a:solidFill>
+                <a:latin typeface="Malgun Gothic" pitchFamily="34" charset="0"/>
+                <a:ea typeface="Malgun Gothic" pitchFamily="34" charset="-122"/>
+                <a:cs typeface="Malgun Gothic" pitchFamily="34" charset="-120"/>
+              </a:rPr>
+              <a:t>공통 인터페이스</a:t>
+            </a:r>
+            <a:endParaRPr lang="en-US" sz="1200" dirty="0"/>
+          </a:p>
+        </p:txBody>
+      </p:sp>
+      <p:sp>
+        <p:nvSpPr>
+          <p:cNvPr id="26" name="Text 22"/>
+          <p:cNvSpPr/>
+          <p:nvPr/>
+        </p:nvSpPr>
+        <p:spPr>
+          <a:xfrm>
+            <a:off x="4023360" y="4718304"/>
+            <a:ext cx="201168" cy="731520"/>
+          </a:xfrm>
+          <a:prstGeom prst="rect">
+            <a:avLst/>
+          </a:prstGeom>
+          <a:noFill/>
+          <a:ln/>
+        </p:spPr>
+        <p:txBody>
+          <a:bodyPr wrap="square" lIns="0" tIns="0" rIns="0" bIns="0" rtlCol="0" anchor="ctr"/>
+          <a:lstStyle/>
+          <a:p>
+            <a:pPr algn="ctr" indent="0" marL="0">
+              <a:buNone/>
+            </a:pPr>
+            <a:r>
+              <a:rPr lang="en-US" sz="1050" dirty="0">
+                <a:solidFill>
+                  <a:srgbClr val="5A7184"/>
+                </a:solidFill>
+                <a:latin typeface="Malgun Gothic" pitchFamily="34" charset="0"/>
+                <a:ea typeface="Malgun Gothic" pitchFamily="34" charset="-122"/>
+                <a:cs typeface="Malgun Gothic" pitchFamily="34" charset="-120"/>
+              </a:rPr>
+              <a:t>▶</a:t>
+            </a:r>
+            <a:endParaRPr lang="en-US" sz="1050" dirty="0"/>
+          </a:p>
+        </p:txBody>
+      </p:sp>
+      <p:sp>
+        <p:nvSpPr>
+          <p:cNvPr id="27" name="Text 23"/>
+          <p:cNvSpPr/>
+          <p:nvPr/>
+        </p:nvSpPr>
+        <p:spPr>
+          <a:xfrm>
+            <a:off x="4224528" y="4718304"/>
+            <a:ext cx="1682496" cy="731520"/>
+          </a:xfrm>
+          <a:prstGeom prst="roundRect">
+            <a:avLst>
+              <a:gd name="adj" fmla="val 8750"/>
+            </a:avLst>
+          </a:prstGeom>
+          <a:solidFill>
+            <a:srgbClr val="E8F6F0"/>
+          </a:solidFill>
+          <a:ln w="15875">
+            <a:solidFill>
+              <a:srgbClr val="02A878"/>
+            </a:solidFill>
+          </a:ln>
+        </p:spPr>
+        <p:txBody>
+          <a:bodyPr wrap="square" lIns="0" tIns="0" rIns="0" bIns="0" rtlCol="0" anchor="ctr"/>
+          <a:lstStyle/>
+          <a:p>
+            <a:pPr algn="ctr" indent="0" marL="0">
+              <a:lnSpc>
+                <a:spcPct val="105000"/>
+              </a:lnSpc>
+              <a:buNone/>
+            </a:pPr>
+            <a:r>
+              <a:rPr lang="en-US" sz="1200" b="1" dirty="0">
+                <a:solidFill>
+                  <a:srgbClr val="02A878"/>
+                </a:solidFill>
+                <a:latin typeface="Malgun Gothic" pitchFamily="34" charset="0"/>
+                <a:ea typeface="Malgun Gothic" pitchFamily="34" charset="-122"/>
+                <a:cs typeface="Malgun Gothic" pitchFamily="34" charset="-120"/>
+              </a:rPr>
+              <a:t>시스템 SW</a:t>
+            </a:r>
+            <a:endParaRPr lang="en-US" sz="1200" dirty="0"/>
+          </a:p>
+          <a:p>
+            <a:pPr algn="ctr" indent="0" marL="0">
+              <a:lnSpc>
+                <a:spcPct val="105000"/>
+              </a:lnSpc>
+              <a:buNone/>
+            </a:pPr>
+            <a:r>
+              <a:rPr lang="en-US" sz="950" dirty="0">
+                <a:solidFill>
+                  <a:srgbClr val="5A7184"/>
+                </a:solidFill>
+                <a:latin typeface="Malgun Gothic" pitchFamily="34" charset="0"/>
+                <a:ea typeface="Malgun Gothic" pitchFamily="34" charset="-122"/>
+                <a:cs typeface="Malgun Gothic" pitchFamily="34" charset="-120"/>
+              </a:rPr>
+              <a:t>워크로드→정책 변환</a:t>
+            </a:r>
+            <a:endParaRPr lang="en-US" sz="1200" dirty="0"/>
+          </a:p>
+        </p:txBody>
+      </p:sp>
+      <p:sp>
+        <p:nvSpPr>
+          <p:cNvPr id="28" name="Text 24"/>
+          <p:cNvSpPr/>
+          <p:nvPr/>
+        </p:nvSpPr>
+        <p:spPr>
+          <a:xfrm>
+            <a:off x="5907024" y="4718304"/>
+            <a:ext cx="201168" cy="731520"/>
+          </a:xfrm>
+          <a:prstGeom prst="rect">
+            <a:avLst/>
+          </a:prstGeom>
+          <a:noFill/>
+          <a:ln/>
+        </p:spPr>
+        <p:txBody>
+          <a:bodyPr wrap="square" lIns="0" tIns="0" rIns="0" bIns="0" rtlCol="0" anchor="ctr"/>
+          <a:lstStyle/>
+          <a:p>
+            <a:pPr algn="ctr" indent="0" marL="0">
+              <a:buNone/>
+            </a:pPr>
+            <a:r>
+              <a:rPr lang="en-US" sz="1050" dirty="0">
+                <a:solidFill>
+                  <a:srgbClr val="5A7184"/>
+                </a:solidFill>
+                <a:latin typeface="Malgun Gothic" pitchFamily="34" charset="0"/>
+                <a:ea typeface="Malgun Gothic" pitchFamily="34" charset="-122"/>
+                <a:cs typeface="Malgun Gothic" pitchFamily="34" charset="-120"/>
+              </a:rPr>
+              <a:t>▶</a:t>
+            </a:r>
+            <a:endParaRPr lang="en-US" sz="1050" dirty="0"/>
+          </a:p>
+        </p:txBody>
+      </p:sp>
+      <p:sp>
+        <p:nvSpPr>
+          <p:cNvPr id="29" name="Text 25"/>
+          <p:cNvSpPr/>
+          <p:nvPr/>
+        </p:nvSpPr>
+        <p:spPr>
+          <a:xfrm>
+            <a:off x="6108192" y="4718304"/>
+            <a:ext cx="1682496" cy="731520"/>
+          </a:xfrm>
+          <a:prstGeom prst="roundRect">
+            <a:avLst>
+              <a:gd name="adj" fmla="val 8750"/>
+            </a:avLst>
+          </a:prstGeom>
+          <a:solidFill>
+            <a:srgbClr val="FFFFFF"/>
+          </a:solidFill>
+          <a:ln w="12700">
+            <a:solidFill>
+              <a:srgbClr val="DCE4E9"/>
+            </a:solidFill>
+          </a:ln>
+        </p:spPr>
+        <p:txBody>
+          <a:bodyPr wrap="square" lIns="0" tIns="0" rIns="0" bIns="0" rtlCol="0" anchor="ctr"/>
+          <a:lstStyle/>
+          <a:p>
+            <a:pPr algn="ctr" indent="0" marL="0">
+              <a:lnSpc>
+                <a:spcPct val="105000"/>
+              </a:lnSpc>
+              <a:buNone/>
+            </a:pPr>
+            <a:r>
+              <a:rPr lang="en-US" sz="1200" b="1" dirty="0">
+                <a:solidFill>
+                  <a:srgbClr val="17313B"/>
+                </a:solidFill>
+                <a:latin typeface="Malgun Gothic" pitchFamily="34" charset="0"/>
+                <a:ea typeface="Malgun Gothic" pitchFamily="34" charset="-122"/>
+                <a:cs typeface="Malgun Gothic" pitchFamily="34" charset="-120"/>
+              </a:rPr>
+              <a:t>E2E 검증</a:t>
+            </a:r>
+            <a:endParaRPr lang="en-US" sz="1200" dirty="0"/>
+          </a:p>
+          <a:p>
+            <a:pPr algn="ctr" indent="0" marL="0">
+              <a:lnSpc>
+                <a:spcPct val="105000"/>
+              </a:lnSpc>
+              <a:buNone/>
+            </a:pPr>
+            <a:r>
+              <a:rPr lang="en-US" sz="950" dirty="0">
+                <a:solidFill>
+                  <a:srgbClr val="5A7184"/>
+                </a:solidFill>
+                <a:latin typeface="Malgun Gothic" pitchFamily="34" charset="0"/>
+                <a:ea typeface="Malgun Gothic" pitchFamily="34" charset="-122"/>
+                <a:cs typeface="Malgun Gothic" pitchFamily="34" charset="-120"/>
+              </a:rPr>
+              <a:t>TCO 개선 보장</a:t>
+            </a:r>
+            <a:endParaRPr lang="en-US" sz="1200" dirty="0"/>
+          </a:p>
+        </p:txBody>
+      </p:sp>
+      <p:sp>
+        <p:nvSpPr>
+          <p:cNvPr id="30" name="Text 26"/>
+          <p:cNvSpPr/>
+          <p:nvPr/>
+        </p:nvSpPr>
+        <p:spPr>
+          <a:xfrm>
+            <a:off x="7790688" y="4718304"/>
+            <a:ext cx="201168" cy="731520"/>
+          </a:xfrm>
+          <a:prstGeom prst="rect">
+            <a:avLst/>
+          </a:prstGeom>
+          <a:noFill/>
+          <a:ln/>
+        </p:spPr>
+        <p:txBody>
+          <a:bodyPr wrap="square" lIns="0" tIns="0" rIns="0" bIns="0" rtlCol="0" anchor="ctr"/>
+          <a:lstStyle/>
+          <a:p>
+            <a:pPr algn="ctr" indent="0" marL="0">
+              <a:buNone/>
+            </a:pPr>
+            <a:r>
+              <a:rPr lang="en-US" sz="1050" dirty="0">
+                <a:solidFill>
+                  <a:srgbClr val="5A7184"/>
+                </a:solidFill>
+                <a:latin typeface="Malgun Gothic" pitchFamily="34" charset="0"/>
+                <a:ea typeface="Malgun Gothic" pitchFamily="34" charset="-122"/>
+                <a:cs typeface="Malgun Gothic" pitchFamily="34" charset="-120"/>
+              </a:rPr>
+              <a:t>▶</a:t>
+            </a:r>
+            <a:endParaRPr lang="en-US" sz="1050" dirty="0"/>
+          </a:p>
+        </p:txBody>
+      </p:sp>
+      <p:sp>
+        <p:nvSpPr>
+          <p:cNvPr id="31" name="Text 27"/>
+          <p:cNvSpPr/>
+          <p:nvPr/>
+        </p:nvSpPr>
+        <p:spPr>
+          <a:xfrm>
+            <a:off x="7991856" y="4718304"/>
+            <a:ext cx="1682496" cy="731520"/>
+          </a:xfrm>
+          <a:prstGeom prst="roundRect">
+            <a:avLst>
+              <a:gd name="adj" fmla="val 8750"/>
+            </a:avLst>
+          </a:prstGeom>
+          <a:solidFill>
+            <a:srgbClr val="FFFFFF"/>
+          </a:solidFill>
+          <a:ln w="12700">
+            <a:solidFill>
+              <a:srgbClr val="DCE4E9"/>
+            </a:solidFill>
+          </a:ln>
+        </p:spPr>
+        <p:txBody>
+          <a:bodyPr wrap="square" lIns="0" tIns="0" rIns="0" bIns="0" rtlCol="0" anchor="ctr"/>
+          <a:lstStyle/>
+          <a:p>
+            <a:pPr algn="ctr" indent="0" marL="0">
+              <a:lnSpc>
+                <a:spcPct val="105000"/>
+              </a:lnSpc>
+              <a:buNone/>
+            </a:pPr>
+            <a:r>
+              <a:rPr lang="en-US" sz="1200" b="1" dirty="0">
+                <a:solidFill>
+                  <a:srgbClr val="17313B"/>
+                </a:solidFill>
+                <a:latin typeface="Malgun Gothic" pitchFamily="34" charset="0"/>
+                <a:ea typeface="Malgun Gothic" pitchFamily="34" charset="-122"/>
+                <a:cs typeface="Malgun Gothic" pitchFamily="34" charset="-120"/>
+              </a:rPr>
+              <a:t>고객 공동개발</a:t>
+            </a:r>
+            <a:endParaRPr lang="en-US" sz="1200" dirty="0"/>
+          </a:p>
+          <a:p>
+            <a:pPr algn="ctr" indent="0" marL="0">
+              <a:lnSpc>
+                <a:spcPct val="105000"/>
+              </a:lnSpc>
+              <a:buNone/>
+            </a:pPr>
+            <a:r>
+              <a:rPr lang="en-US" sz="950" dirty="0">
+                <a:solidFill>
+                  <a:srgbClr val="5A7184"/>
+                </a:solidFill>
+                <a:latin typeface="Malgun Gothic" pitchFamily="34" charset="0"/>
+                <a:ea typeface="Malgun Gothic" pitchFamily="34" charset="-122"/>
+                <a:cs typeface="Malgun Gothic" pitchFamily="34" charset="-120"/>
+              </a:rPr>
+              <a:t>장기 관계 구축</a:t>
+            </a:r>
+            <a:endParaRPr lang="en-US" sz="1200" dirty="0"/>
+          </a:p>
+        </p:txBody>
+      </p:sp>
+      <p:sp>
+        <p:nvSpPr>
+          <p:cNvPr id="32" name="Text 28"/>
+          <p:cNvSpPr/>
+          <p:nvPr/>
+        </p:nvSpPr>
+        <p:spPr>
+          <a:xfrm>
+            <a:off x="9674352" y="4718304"/>
+            <a:ext cx="201168" cy="731520"/>
+          </a:xfrm>
+          <a:prstGeom prst="rect">
+            <a:avLst/>
+          </a:prstGeom>
+          <a:noFill/>
+          <a:ln/>
+        </p:spPr>
+        <p:txBody>
+          <a:bodyPr wrap="square" lIns="0" tIns="0" rIns="0" bIns="0" rtlCol="0" anchor="ctr"/>
+          <a:lstStyle/>
+          <a:p>
+            <a:pPr algn="ctr" indent="0" marL="0">
+              <a:buNone/>
+            </a:pPr>
+            <a:r>
+              <a:rPr lang="en-US" sz="1050" dirty="0">
+                <a:solidFill>
+                  <a:srgbClr val="5A7184"/>
+                </a:solidFill>
+                <a:latin typeface="Malgun Gothic" pitchFamily="34" charset="0"/>
+                <a:ea typeface="Malgun Gothic" pitchFamily="34" charset="-122"/>
+                <a:cs typeface="Malgun Gothic" pitchFamily="34" charset="-120"/>
+              </a:rPr>
+              <a:t>▶</a:t>
+            </a:r>
+            <a:endParaRPr lang="en-US" sz="1050" dirty="0"/>
+          </a:p>
+        </p:txBody>
+      </p:sp>
+      <p:sp>
+        <p:nvSpPr>
+          <p:cNvPr id="33" name="Text 29"/>
+          <p:cNvSpPr/>
+          <p:nvPr/>
+        </p:nvSpPr>
+        <p:spPr>
+          <a:xfrm>
+            <a:off x="9875520" y="4718304"/>
+            <a:ext cx="1682496" cy="731520"/>
+          </a:xfrm>
+          <a:prstGeom prst="roundRect">
+            <a:avLst>
+              <a:gd name="adj" fmla="val 8750"/>
+            </a:avLst>
+          </a:prstGeom>
+          <a:solidFill>
+            <a:srgbClr val="FFFFFF"/>
+          </a:solidFill>
+          <a:ln w="12700">
+            <a:solidFill>
+              <a:srgbClr val="DCE4E9"/>
+            </a:solidFill>
+          </a:ln>
+        </p:spPr>
+        <p:txBody>
+          <a:bodyPr wrap="square" lIns="0" tIns="0" rIns="0" bIns="0" rtlCol="0" anchor="ctr"/>
+          <a:lstStyle/>
+          <a:p>
+            <a:pPr algn="ctr" indent="0" marL="0">
+              <a:lnSpc>
+                <a:spcPct val="105000"/>
+              </a:lnSpc>
+              <a:buNone/>
+            </a:pPr>
+            <a:r>
+              <a:rPr lang="en-US" sz="1200" b="1" dirty="0">
+                <a:solidFill>
+                  <a:srgbClr val="17313B"/>
+                </a:solidFill>
+                <a:latin typeface="Malgun Gothic" pitchFamily="34" charset="0"/>
+                <a:ea typeface="Malgun Gothic" pitchFamily="34" charset="-122"/>
+                <a:cs typeface="Malgun Gothic" pitchFamily="34" charset="-120"/>
+              </a:rPr>
+              <a:t>텔레메트리</a:t>
+            </a:r>
+            <a:endParaRPr lang="en-US" sz="1200" dirty="0"/>
+          </a:p>
+          <a:p>
+            <a:pPr algn="ctr" indent="0" marL="0">
+              <a:lnSpc>
+                <a:spcPct val="105000"/>
+              </a:lnSpc>
+              <a:buNone/>
+            </a:pPr>
+            <a:r>
+              <a:rPr lang="en-US" sz="950" dirty="0">
+                <a:solidFill>
+                  <a:srgbClr val="5A7184"/>
+                </a:solidFill>
+                <a:latin typeface="Malgun Gothic" pitchFamily="34" charset="0"/>
+                <a:ea typeface="Malgun Gothic" pitchFamily="34" charset="-122"/>
+                <a:cs typeface="Malgun Gothic" pitchFamily="34" charset="-120"/>
+              </a:rPr>
+              <a:t>지속 개선 루프</a:t>
+            </a:r>
+            <a:endParaRPr lang="en-US" sz="1200" dirty="0"/>
+          </a:p>
+        </p:txBody>
+      </p:sp>
+      <p:sp>
+        <p:nvSpPr>
+          <p:cNvPr id="34" name="Text 30"/>
+          <p:cNvSpPr/>
+          <p:nvPr/>
+        </p:nvSpPr>
+        <p:spPr>
+          <a:xfrm>
+            <a:off x="457200" y="5742432"/>
+            <a:ext cx="11274552" cy="274320"/>
+          </a:xfrm>
+          <a:prstGeom prst="rect">
+            <a:avLst/>
+          </a:prstGeom>
+          <a:noFill/>
+          <a:ln/>
+        </p:spPr>
+        <p:txBody>
+          <a:bodyPr wrap="square" lIns="0" tIns="0" rIns="0" bIns="0" rtlCol="0" anchor="ctr"/>
+          <a:lstStyle/>
+          <a:p>
+            <a:pPr algn="ctr" indent="0" marL="0">
+              <a:buNone/>
+            </a:pPr>
+            <a:r>
+              <a:rPr lang="en-US" sz="1200" i="1" dirty="0">
+                <a:solidFill>
+                  <a:srgbClr val="5A7184"/>
+                </a:solidFill>
+                <a:latin typeface="Malgun Gothic" pitchFamily="34" charset="0"/>
+                <a:ea typeface="Malgun Gothic" pitchFamily="34" charset="-122"/>
+                <a:cs typeface="Malgun Gothic" pitchFamily="34" charset="-120"/>
+              </a:rPr>
+              <a:t>Captive 고객의 요구를 삼성 완제품 생태계 안에 수용한다 — Binding secures demand · FDP standardizes · System SW creates value</a:t>
+            </a:r>
+            <a:endParaRPr lang="en-US" sz="1200" dirty="0"/>
+          </a:p>
+        </p:txBody>
+      </p:sp>
+    </p:spTree>
+  </p:cSld>
+  <p:clrMapOvr>
+    <a:masterClrMapping/>
+  </p:clrMapOvr>
+</p:sld>
+</file>
+
+<file path=ppt/slides/slide5.xml><?xml version="1.0" encoding="utf-8"?>
+<p:sld xmlns:a="http://schemas.openxmlformats.org/drawingml/2006/main" xmlns:r="http://schemas.openxmlformats.org/officeDocument/2006/relationships" xmlns:p="http://schemas.openxmlformats.org/presentationml/2006/main">
+  <p:cSld name="Slide 5">
+    <p:spTree>
+      <p:nvGrpSpPr>
+        <p:cNvPr id="1" name=""/>
+        <p:cNvGrpSpPr/>
+        <p:nvPr/>
+      </p:nvGrpSpPr>
+      <p:grpSpPr>
+        <a:xfrm>
+          <a:off x="0" y="0"/>
+          <a:ext cx="0" cy="0"/>
+          <a:chOff x="0" y="0"/>
+          <a:chExt cx="0" cy="0"/>
+        </a:xfrm>
+      </p:grpSpPr>
+      <p:sp>
+        <p:nvSpPr>
+          <p:cNvPr id="2" name="Text 0"/>
+          <p:cNvSpPr/>
+          <p:nvPr/>
+        </p:nvSpPr>
+        <p:spPr>
+          <a:xfrm>
+            <a:off x="457200" y="237744"/>
+            <a:ext cx="9765792" cy="566928"/>
+          </a:xfrm>
+          <a:prstGeom prst="rect">
+            <a:avLst/>
+          </a:prstGeom>
+          <a:noFill/>
+          <a:ln/>
+        </p:spPr>
+        <p:txBody>
+          <a:bodyPr wrap="square" lIns="0" tIns="0" rIns="0" bIns="0" rtlCol="0" anchor="ctr"/>
+          <a:lstStyle/>
+          <a:p>
+            <a:pPr indent="0" marL="0">
+              <a:buNone/>
+            </a:pPr>
+            <a:r>
+              <a:rPr lang="en-US" sz="3200" b="1" dirty="0">
+                <a:solidFill>
+                  <a:srgbClr val="17313B"/>
+                </a:solidFill>
+                <a:latin typeface="Malgun Gothic" pitchFamily="34" charset="0"/>
+                <a:ea typeface="Malgun Gothic" pitchFamily="34" charset="-122"/>
+                <a:cs typeface="Malgun Gothic" pitchFamily="34" charset="-120"/>
+              </a:rPr>
+              <a:t>제품·기술 축 — FDP Host–SSD 통합 플랫폼</a:t>
+            </a:r>
+            <a:endParaRPr lang="en-US" sz="3200" dirty="0"/>
+          </a:p>
+        </p:txBody>
+      </p:sp>
+      <p:sp>
+        <p:nvSpPr>
+          <p:cNvPr id="3" name="Text 1"/>
+          <p:cNvSpPr/>
+          <p:nvPr/>
+        </p:nvSpPr>
+        <p:spPr>
+          <a:xfrm>
+            <a:off x="10268712" y="310896"/>
+            <a:ext cx="1463040" cy="420624"/>
+          </a:xfrm>
+          <a:prstGeom prst="roundRect">
+            <a:avLst>
+              <a:gd name="adj" fmla="val 21739"/>
+            </a:avLst>
+          </a:prstGeom>
+          <a:solidFill>
+            <a:srgbClr val="EFF3F5"/>
+          </a:solidFill>
+          <a:ln/>
+        </p:spPr>
+        <p:txBody>
+          <a:bodyPr wrap="square" lIns="0" tIns="0" rIns="0" bIns="0" rtlCol="0" anchor="ctr"/>
+          <a:lstStyle/>
+          <a:p>
+            <a:pPr algn="ctr" indent="0" marL="0">
+              <a:buNone/>
+            </a:pPr>
+            <a:r>
+              <a:rPr lang="en-US" sz="1400" b="1" dirty="0">
+                <a:solidFill>
+                  <a:srgbClr val="5A7184"/>
+                </a:solidFill>
+                <a:latin typeface="Malgun Gothic" pitchFamily="34" charset="0"/>
+                <a:ea typeface="Malgun Gothic" pitchFamily="34" charset="-122"/>
+                <a:cs typeface="Malgun Gothic" pitchFamily="34" charset="-120"/>
+              </a:rPr>
+              <a:t>제품 축 ②</a:t>
+            </a:r>
+            <a:endParaRPr lang="en-US" sz="1400" dirty="0"/>
+          </a:p>
+        </p:txBody>
+      </p:sp>
+      <p:sp>
+        <p:nvSpPr>
+          <p:cNvPr id="4" name="Text 2"/>
+          <p:cNvSpPr/>
+          <p:nvPr/>
+        </p:nvSpPr>
+        <p:spPr>
+          <a:xfrm>
+            <a:off x="457200" y="6510528"/>
+            <a:ext cx="6949440" cy="256032"/>
+          </a:xfrm>
+          <a:prstGeom prst="rect">
+            <a:avLst/>
+          </a:prstGeom>
+          <a:noFill/>
+          <a:ln/>
+        </p:spPr>
+        <p:txBody>
+          <a:bodyPr wrap="square" lIns="0" tIns="0" rIns="0" bIns="0" rtlCol="0" anchor="ctr"/>
+          <a:lstStyle/>
+          <a:p>
+            <a:pPr indent="0" marL="0">
+              <a:buNone/>
+            </a:pPr>
+            <a:r>
+              <a:rPr lang="en-US" sz="1000" dirty="0">
+                <a:solidFill>
+                  <a:srgbClr val="5A7184"/>
+                </a:solidFill>
+                <a:latin typeface="Malgun Gothic" pitchFamily="34" charset="0"/>
+                <a:ea typeface="Malgun Gothic" pitchFamily="34" charset="-122"/>
+                <a:cs typeface="Malgun Gothic" pitchFamily="34" charset="-120"/>
+              </a:rPr>
+              <a:t>삼성전자 메모리사업부 · 개발실 체질 전환 전략 요약 · 2026-07-24</a:t>
+            </a:r>
+            <a:endParaRPr lang="en-US" sz="1000" dirty="0"/>
+          </a:p>
+        </p:txBody>
+      </p:sp>
+      <p:sp>
+        <p:nvSpPr>
+          <p:cNvPr id="5" name="Text 3"/>
+          <p:cNvSpPr/>
+          <p:nvPr/>
+        </p:nvSpPr>
+        <p:spPr>
+          <a:xfrm>
+            <a:off x="7589520" y="6510528"/>
+            <a:ext cx="4142232" cy="256032"/>
+          </a:xfrm>
+          <a:prstGeom prst="rect">
+            <a:avLst/>
+          </a:prstGeom>
+          <a:noFill/>
+          <a:ln/>
+        </p:spPr>
+        <p:txBody>
+          <a:bodyPr wrap="square" lIns="0" tIns="0" rIns="0" bIns="0" rtlCol="0" anchor="ctr"/>
+          <a:lstStyle/>
+          <a:p>
+            <a:pPr algn="r" indent="0" marL="0">
+              <a:buNone/>
+            </a:pPr>
+            <a:r>
+              <a:rPr lang="en-US" sz="1000" dirty="0">
+                <a:solidFill>
+                  <a:srgbClr val="5A7184"/>
+                </a:solidFill>
+                <a:latin typeface="Malgun Gothic" pitchFamily="34" charset="0"/>
+                <a:ea typeface="Malgun Gothic" pitchFamily="34" charset="-122"/>
+                <a:cs typeface="Malgun Gothic" pitchFamily="34" charset="-120"/>
+              </a:rPr>
+              <a:t>원천: wiki/strategies/fdp-host-ssd-platform.md</a:t>
+            </a:r>
+            <a:endParaRPr lang="en-US" sz="1000" dirty="0"/>
+          </a:p>
+        </p:txBody>
+      </p:sp>
+      <p:sp>
+        <p:nvSpPr>
+          <p:cNvPr id="6" name="Text 4"/>
+          <p:cNvSpPr/>
+          <p:nvPr/>
+        </p:nvSpPr>
+        <p:spPr>
+          <a:xfrm>
+            <a:off x="457200" y="859536"/>
+            <a:ext cx="7315200" cy="310896"/>
+          </a:xfrm>
+          <a:prstGeom prst="rect">
+            <a:avLst/>
+          </a:prstGeom>
+          <a:noFill/>
+          <a:ln/>
+        </p:spPr>
+        <p:txBody>
+          <a:bodyPr wrap="square" lIns="0" tIns="0" rIns="0" bIns="0" rtlCol="0" anchor="ctr"/>
+          <a:lstStyle/>
+          <a:p>
+            <a:pPr indent="0" marL="0">
+              <a:buNone/>
+            </a:pPr>
+            <a:r>
+              <a:rPr lang="en-US" sz="1600" b="1" dirty="0">
+                <a:solidFill>
+                  <a:srgbClr val="17313B"/>
+                </a:solidFill>
+                <a:latin typeface="Malgun Gothic" pitchFamily="34" charset="0"/>
+                <a:ea typeface="Malgun Gothic" pitchFamily="34" charset="-122"/>
+                <a:cs typeface="Malgun Gothic" pitchFamily="34" charset="-120"/>
+              </a:rPr>
+              <a:t>실행전략 6종 — Samsung FDP Enablement</a:t>
+            </a:r>
+            <a:endParaRPr lang="en-US" sz="1600" dirty="0"/>
+          </a:p>
+        </p:txBody>
+      </p:sp>
+      <p:sp>
+        <p:nvSpPr>
+          <p:cNvPr id="7" name="Shape 5"/>
+          <p:cNvSpPr/>
+          <p:nvPr/>
+        </p:nvSpPr>
+        <p:spPr>
+          <a:xfrm>
+            <a:off x="457200" y="1280160"/>
+            <a:ext cx="3602736" cy="1737360"/>
+          </a:xfrm>
+          <a:prstGeom prst="roundRect">
+            <a:avLst>
+              <a:gd name="adj" fmla="val 4737"/>
+            </a:avLst>
+          </a:prstGeom>
+          <a:solidFill>
+            <a:srgbClr val="F5F7F8"/>
+          </a:solidFill>
+          <a:ln/>
+        </p:spPr>
+      </p:sp>
+      <p:sp>
+        <p:nvSpPr>
+          <p:cNvPr id="8" name="Shape 6"/>
+          <p:cNvSpPr/>
+          <p:nvPr/>
+        </p:nvSpPr>
+        <p:spPr>
+          <a:xfrm>
+            <a:off x="640080" y="1444752"/>
+            <a:ext cx="402336" cy="402336"/>
+          </a:xfrm>
+          <a:prstGeom prst="ellipse">
+            <a:avLst/>
+          </a:prstGeom>
+          <a:solidFill>
+            <a:srgbClr val="0E6BA8"/>
+          </a:solidFill>
+          <a:ln/>
+        </p:spPr>
+      </p:sp>
+      <p:pic>
+        <p:nvPicPr>
+          <p:cNvPr id="9" name="Image 0" descr="preencoded.png">    </p:cNvPr>
+          <p:cNvPicPr>
+            <a:picLocks noChangeAspect="1"/>
+          </p:cNvPicPr>
+          <p:nvPr/>
+        </p:nvPicPr>
+        <p:blipFill>
+          <a:blip r:embed="rId1"/>
+          <a:stretch>
+            <a:fillRect/>
+          </a:stretch>
+        </p:blipFill>
+        <p:spPr>
+          <a:xfrm>
+            <a:off x="736641" y="1541313"/>
+            <a:ext cx="209215" cy="209215"/>
+          </a:xfrm>
+          <a:prstGeom prst="rect">
+            <a:avLst/>
+          </a:prstGeom>
+        </p:spPr>
+      </p:pic>
+      <p:sp>
+        <p:nvSpPr>
+          <p:cNvPr id="10" name="Text 7"/>
+          <p:cNvSpPr/>
+          <p:nvPr/>
+        </p:nvSpPr>
+        <p:spPr>
+          <a:xfrm>
+            <a:off x="1152144" y="1463040"/>
+            <a:ext cx="2743200" cy="365760"/>
+          </a:xfrm>
+          <a:prstGeom prst="rect">
+            <a:avLst/>
+          </a:prstGeom>
+          <a:noFill/>
+          <a:ln/>
+        </p:spPr>
+        <p:txBody>
+          <a:bodyPr wrap="square" lIns="0" tIns="0" rIns="0" bIns="0" rtlCol="0" anchor="ctr"/>
+          <a:lstStyle/>
+          <a:p>
+            <a:pPr indent="0" marL="0">
+              <a:buNone/>
+            </a:pPr>
+            <a:r>
+              <a:rPr lang="en-US" sz="1400" b="1" dirty="0">
+                <a:solidFill>
+                  <a:srgbClr val="17313B"/>
+                </a:solidFill>
+                <a:latin typeface="Malgun Gothic" pitchFamily="34" charset="0"/>
+                <a:ea typeface="Malgun Gothic" pitchFamily="34" charset="-122"/>
+                <a:cs typeface="Malgun Gothic" pitchFamily="34" charset="-120"/>
+              </a:rPr>
+              <a:t>1. Enablement Platform</a:t>
+            </a:r>
+            <a:endParaRPr lang="en-US" sz="1400" dirty="0"/>
+          </a:p>
+        </p:txBody>
+      </p:sp>
+      <p:sp>
+        <p:nvSpPr>
+          <p:cNvPr id="11" name="Text 8"/>
+          <p:cNvSpPr/>
+          <p:nvPr/>
+        </p:nvSpPr>
+        <p:spPr>
+          <a:xfrm>
+            <a:off x="658368" y="1956816"/>
+            <a:ext cx="3200400" cy="969264"/>
+          </a:xfrm>
+          <a:prstGeom prst="rect">
+            <a:avLst/>
+          </a:prstGeom>
+          <a:noFill/>
+          <a:ln/>
+        </p:spPr>
+        <p:txBody>
+          <a:bodyPr wrap="square" lIns="0" tIns="0" rIns="0" bIns="0" rtlCol="0" anchor="t"/>
+          <a:lstStyle/>
+          <a:p>
+            <a:pPr indent="0" marL="0">
+              <a:lnSpc>
+                <a:spcPct val="112000"/>
+              </a:lnSpc>
+              <a:buNone/>
+            </a:pPr>
+            <a:r>
+              <a:rPr lang="en-US" sz="1050" dirty="0">
+                <a:solidFill>
+                  <a:srgbClr val="5A7184"/>
+                </a:solidFill>
+                <a:latin typeface="Malgun Gothic" pitchFamily="34" charset="0"/>
+                <a:ea typeface="Malgun Gothic" pitchFamily="34" charset="-122"/>
+                <a:cs typeface="Malgun Gothic" pitchFamily="34" charset="-120"/>
+              </a:rPr>
+              <a:t>FDP SDK·공통 라이브러리 (Linux·io_uring·SPDK) · Workload Profiler(trace→추천 RUH·예상 WAF) · Emulator/Digital Twin</a:t>
+            </a:r>
+            <a:endParaRPr lang="en-US" sz="1050" dirty="0"/>
+          </a:p>
+        </p:txBody>
+      </p:sp>
+      <p:sp>
+        <p:nvSpPr>
+          <p:cNvPr id="12" name="Shape 9"/>
+          <p:cNvSpPr/>
+          <p:nvPr/>
+        </p:nvSpPr>
+        <p:spPr>
+          <a:xfrm>
+            <a:off x="4297680" y="1280160"/>
+            <a:ext cx="3602736" cy="1737360"/>
+          </a:xfrm>
+          <a:prstGeom prst="roundRect">
+            <a:avLst>
+              <a:gd name="adj" fmla="val 4737"/>
+            </a:avLst>
+          </a:prstGeom>
+          <a:solidFill>
+            <a:srgbClr val="F5F7F8"/>
+          </a:solidFill>
+          <a:ln/>
+        </p:spPr>
+      </p:sp>
+      <p:sp>
+        <p:nvSpPr>
+          <p:cNvPr id="13" name="Shape 10"/>
+          <p:cNvSpPr/>
+          <p:nvPr/>
+        </p:nvSpPr>
+        <p:spPr>
+          <a:xfrm>
+            <a:off x="4480560" y="1444752"/>
+            <a:ext cx="402336" cy="402336"/>
+          </a:xfrm>
+          <a:prstGeom prst="ellipse">
+            <a:avLst/>
+          </a:prstGeom>
+          <a:solidFill>
+            <a:srgbClr val="028090"/>
+          </a:solidFill>
+          <a:ln/>
+        </p:spPr>
+      </p:sp>
+      <p:pic>
+        <p:nvPicPr>
+          <p:cNvPr id="14" name="Image 1" descr="preencoded.png">    </p:cNvPr>
+          <p:cNvPicPr>
+            <a:picLocks noChangeAspect="1"/>
+          </p:cNvPicPr>
+          <p:nvPr/>
+        </p:nvPicPr>
+        <p:blipFill>
+          <a:blip r:embed="rId2"/>
+          <a:stretch>
+            <a:fillRect/>
+          </a:stretch>
+        </p:blipFill>
+        <p:spPr>
+          <a:xfrm>
+            <a:off x="4577121" y="1541313"/>
+            <a:ext cx="209215" cy="209215"/>
+          </a:xfrm>
+          <a:prstGeom prst="rect">
+            <a:avLst/>
+          </a:prstGeom>
+        </p:spPr>
+      </p:pic>
+      <p:sp>
+        <p:nvSpPr>
+          <p:cNvPr id="15" name="Text 11"/>
+          <p:cNvSpPr/>
+          <p:nvPr/>
+        </p:nvSpPr>
+        <p:spPr>
+          <a:xfrm>
+            <a:off x="4992624" y="1463040"/>
+            <a:ext cx="2743200" cy="365760"/>
+          </a:xfrm>
+          <a:prstGeom prst="rect">
+            <a:avLst/>
+          </a:prstGeom>
+          <a:noFill/>
+          <a:ln/>
+        </p:spPr>
+        <p:txBody>
+          <a:bodyPr wrap="square" lIns="0" tIns="0" rIns="0" bIns="0" rtlCol="0" anchor="ctr"/>
+          <a:lstStyle/>
+          <a:p>
+            <a:pPr indent="0" marL="0">
+              <a:buNone/>
+            </a:pPr>
+            <a:r>
+              <a:rPr lang="en-US" sz="1400" b="1" dirty="0">
+                <a:solidFill>
+                  <a:srgbClr val="17313B"/>
+                </a:solidFill>
+                <a:latin typeface="Malgun Gothic" pitchFamily="34" charset="0"/>
+                <a:ea typeface="Malgun Gothic" pitchFamily="34" charset="-122"/>
+                <a:cs typeface="Malgun Gothic" pitchFamily="34" charset="-120"/>
+              </a:rPr>
+              <a:t>2. 표준 워크로드 프로파일</a:t>
+            </a:r>
+            <a:endParaRPr lang="en-US" sz="1400" dirty="0"/>
+          </a:p>
+        </p:txBody>
+      </p:sp>
+      <p:sp>
+        <p:nvSpPr>
+          <p:cNvPr id="16" name="Text 12"/>
+          <p:cNvSpPr/>
+          <p:nvPr/>
+        </p:nvSpPr>
+        <p:spPr>
+          <a:xfrm>
+            <a:off x="4498848" y="1956816"/>
+            <a:ext cx="3200400" cy="969264"/>
+          </a:xfrm>
+          <a:prstGeom prst="rect">
+            <a:avLst/>
+          </a:prstGeom>
+          <a:noFill/>
+          <a:ln/>
+        </p:spPr>
+        <p:txBody>
+          <a:bodyPr wrap="square" lIns="0" tIns="0" rIns="0" bIns="0" rtlCol="0" anchor="t"/>
+          <a:lstStyle/>
+          <a:p>
+            <a:pPr indent="0" marL="0">
+              <a:lnSpc>
+                <a:spcPct val="112000"/>
+              </a:lnSpc>
+              <a:buNone/>
+            </a:pPr>
+            <a:r>
+              <a:rPr lang="en-US" sz="1050" dirty="0">
+                <a:solidFill>
+                  <a:srgbClr val="5A7184"/>
+                </a:solidFill>
+                <a:latin typeface="Malgun Gothic" pitchFamily="34" charset="0"/>
+                <a:ea typeface="Malgun Gothic" pitchFamily="34" charset="-122"/>
+                <a:cs typeface="Malgun Gothic" pitchFamily="34" charset="-120"/>
+              </a:rPr>
+              <a:t>Cache·KV·DB·Multi-tenant·Vector·Checkpoint·QLC 7종 — 펌웨어 공통화와 고객별 최적화 양립</a:t>
+            </a:r>
+            <a:endParaRPr lang="en-US" sz="1050" dirty="0"/>
+          </a:p>
+        </p:txBody>
+      </p:sp>
+      <p:sp>
+        <p:nvSpPr>
+          <p:cNvPr id="17" name="Shape 13"/>
+          <p:cNvSpPr/>
+          <p:nvPr/>
+        </p:nvSpPr>
+        <p:spPr>
+          <a:xfrm>
+            <a:off x="8138160" y="1280160"/>
+            <a:ext cx="3602736" cy="1737360"/>
+          </a:xfrm>
+          <a:prstGeom prst="roundRect">
+            <a:avLst>
+              <a:gd name="adj" fmla="val 4737"/>
+            </a:avLst>
+          </a:prstGeom>
+          <a:solidFill>
+            <a:srgbClr val="F5F7F8"/>
+          </a:solidFill>
+          <a:ln/>
+        </p:spPr>
+      </p:sp>
+      <p:sp>
+        <p:nvSpPr>
+          <p:cNvPr id="18" name="Shape 14"/>
+          <p:cNvSpPr/>
+          <p:nvPr/>
+        </p:nvSpPr>
+        <p:spPr>
+          <a:xfrm>
+            <a:off x="8321040" y="1444752"/>
+            <a:ext cx="402336" cy="402336"/>
+          </a:xfrm>
+          <a:prstGeom prst="ellipse">
+            <a:avLst/>
+          </a:prstGeom>
+          <a:solidFill>
+            <a:srgbClr val="02A878"/>
+          </a:solidFill>
+          <a:ln/>
+        </p:spPr>
+      </p:sp>
+      <p:pic>
+        <p:nvPicPr>
+          <p:cNvPr id="19" name="Image 2" descr="preencoded.png">    </p:cNvPr>
+          <p:cNvPicPr>
+            <a:picLocks noChangeAspect="1"/>
+          </p:cNvPicPr>
+          <p:nvPr/>
+        </p:nvPicPr>
+        <p:blipFill>
+          <a:blip r:embed="rId3"/>
+          <a:stretch>
+            <a:fillRect/>
+          </a:stretch>
+        </p:blipFill>
+        <p:spPr>
+          <a:xfrm>
+            <a:off x="8417601" y="1541313"/>
+            <a:ext cx="209215" cy="209215"/>
+          </a:xfrm>
+          <a:prstGeom prst="rect">
+            <a:avLst/>
+          </a:prstGeom>
+        </p:spPr>
+      </p:pic>
+      <p:sp>
+        <p:nvSpPr>
+          <p:cNvPr id="20" name="Text 15"/>
+          <p:cNvSpPr/>
+          <p:nvPr/>
+        </p:nvSpPr>
+        <p:spPr>
+          <a:xfrm>
+            <a:off x="8833104" y="1463040"/>
+            <a:ext cx="2743200" cy="365760"/>
+          </a:xfrm>
+          <a:prstGeom prst="rect">
+            <a:avLst/>
+          </a:prstGeom>
+          <a:noFill/>
+          <a:ln/>
+        </p:spPr>
+        <p:txBody>
+          <a:bodyPr wrap="square" lIns="0" tIns="0" rIns="0" bIns="0" rtlCol="0" anchor="ctr"/>
+          <a:lstStyle/>
+          <a:p>
+            <a:pPr indent="0" marL="0">
+              <a:buNone/>
+            </a:pPr>
+            <a:r>
+              <a:rPr lang="en-US" sz="1400" b="1" dirty="0">
+                <a:solidFill>
+                  <a:srgbClr val="17313B"/>
+                </a:solidFill>
+                <a:latin typeface="Malgun Gothic" pitchFamily="34" charset="0"/>
+                <a:ea typeface="Malgun Gothic" pitchFamily="34" charset="-122"/>
+                <a:cs typeface="Malgun Gothic" pitchFamily="34" charset="-120"/>
+              </a:rPr>
+              <a:t>3. End-to-End 공동검증</a:t>
+            </a:r>
+            <a:endParaRPr lang="en-US" sz="1400" dirty="0"/>
+          </a:p>
+        </p:txBody>
+      </p:sp>
+      <p:sp>
+        <p:nvSpPr>
+          <p:cNvPr id="21" name="Text 16"/>
+          <p:cNvSpPr/>
+          <p:nvPr/>
+        </p:nvSpPr>
+        <p:spPr>
+          <a:xfrm>
+            <a:off x="8339328" y="1956816"/>
+            <a:ext cx="3200400" cy="969264"/>
+          </a:xfrm>
+          <a:prstGeom prst="rect">
+            <a:avLst/>
+          </a:prstGeom>
+          <a:noFill/>
+          <a:ln/>
+        </p:spPr>
+        <p:txBody>
+          <a:bodyPr wrap="square" lIns="0" tIns="0" rIns="0" bIns="0" rtlCol="0" anchor="t"/>
+          <a:lstStyle/>
+          <a:p>
+            <a:pPr indent="0" marL="0">
+              <a:lnSpc>
+                <a:spcPct val="112000"/>
+              </a:lnSpc>
+              <a:buNone/>
+            </a:pPr>
+            <a:r>
+              <a:rPr lang="en-US" sz="1050" dirty="0">
+                <a:solidFill>
+                  <a:srgbClr val="5A7184"/>
+                </a:solidFill>
+                <a:latin typeface="Malgun Gothic" pitchFamily="34" charset="0"/>
+                <a:ea typeface="Malgun Gothic" pitchFamily="34" charset="-122"/>
+                <a:cs typeface="Malgun Gothic" pitchFamily="34" charset="-120"/>
+              </a:rPr>
+              <a:t>App→Host→SSD→NAND→텔레메트리 · 시스템 성과 지표(WAF·p999·격리·전력) · 고객 trace의 pre/post-silicon 재사용</a:t>
+            </a:r>
+            <a:endParaRPr lang="en-US" sz="1050" dirty="0"/>
+          </a:p>
+        </p:txBody>
+      </p:sp>
+      <p:sp>
+        <p:nvSpPr>
+          <p:cNvPr id="22" name="Shape 17"/>
+          <p:cNvSpPr/>
+          <p:nvPr/>
+        </p:nvSpPr>
+        <p:spPr>
+          <a:xfrm>
+            <a:off x="457200" y="3163824"/>
+            <a:ext cx="3602736" cy="1737360"/>
+          </a:xfrm>
+          <a:prstGeom prst="roundRect">
+            <a:avLst>
+              <a:gd name="adj" fmla="val 4737"/>
+            </a:avLst>
+          </a:prstGeom>
+          <a:solidFill>
+            <a:srgbClr val="F5F7F8"/>
+          </a:solidFill>
+          <a:ln/>
+        </p:spPr>
+      </p:sp>
+      <p:sp>
+        <p:nvSpPr>
+          <p:cNvPr id="23" name="Shape 18"/>
+          <p:cNvSpPr/>
+          <p:nvPr/>
+        </p:nvSpPr>
+        <p:spPr>
+          <a:xfrm>
+            <a:off x="640080" y="3328416"/>
+            <a:ext cx="402336" cy="402336"/>
+          </a:xfrm>
+          <a:prstGeom prst="ellipse">
+            <a:avLst/>
+          </a:prstGeom>
+          <a:solidFill>
+            <a:srgbClr val="4C7C94"/>
+          </a:solidFill>
+          <a:ln/>
+        </p:spPr>
+      </p:sp>
+      <p:pic>
+        <p:nvPicPr>
+          <p:cNvPr id="24" name="Image 3" descr="preencoded.png">    </p:cNvPr>
+          <p:cNvPicPr>
+            <a:picLocks noChangeAspect="1"/>
+          </p:cNvPicPr>
+          <p:nvPr/>
+        </p:nvPicPr>
+        <p:blipFill>
+          <a:blip r:embed="rId4"/>
+          <a:stretch>
+            <a:fillRect/>
+          </a:stretch>
+        </p:blipFill>
+        <p:spPr>
+          <a:xfrm>
+            <a:off x="736641" y="3424977"/>
+            <a:ext cx="209215" cy="209215"/>
+          </a:xfrm>
+          <a:prstGeom prst="rect">
+            <a:avLst/>
+          </a:prstGeom>
+        </p:spPr>
+      </p:pic>
+      <p:sp>
+        <p:nvSpPr>
+          <p:cNvPr id="25" name="Text 19"/>
+          <p:cNvSpPr/>
+          <p:nvPr/>
+        </p:nvSpPr>
+        <p:spPr>
+          <a:xfrm>
+            <a:off x="1152144" y="3346704"/>
+            <a:ext cx="2743200" cy="365760"/>
+          </a:xfrm>
+          <a:prstGeom prst="rect">
+            <a:avLst/>
+          </a:prstGeom>
+          <a:noFill/>
+          <a:ln/>
+        </p:spPr>
+        <p:txBody>
+          <a:bodyPr wrap="square" lIns="0" tIns="0" rIns="0" bIns="0" rtlCol="0" anchor="ctr"/>
+          <a:lstStyle/>
+          <a:p>
+            <a:pPr indent="0" marL="0">
+              <a:buNone/>
+            </a:pPr>
+            <a:r>
+              <a:rPr lang="en-US" sz="1400" b="1" dirty="0">
+                <a:solidFill>
+                  <a:srgbClr val="17313B"/>
+                </a:solidFill>
+                <a:latin typeface="Malgun Gothic" pitchFamily="34" charset="0"/>
+                <a:ea typeface="Malgun Gothic" pitchFamily="34" charset="-122"/>
+                <a:cs typeface="Malgun Gothic" pitchFamily="34" charset="-120"/>
+              </a:rPr>
+              <a:t>4. 고객 공동개발 조직</a:t>
+            </a:r>
+            <a:endParaRPr lang="en-US" sz="1400" dirty="0"/>
+          </a:p>
+        </p:txBody>
+      </p:sp>
+      <p:sp>
+        <p:nvSpPr>
+          <p:cNvPr id="26" name="Text 20"/>
+          <p:cNvSpPr/>
+          <p:nvPr/>
+        </p:nvSpPr>
+        <p:spPr>
+          <a:xfrm>
+            <a:off x="658368" y="3840480"/>
+            <a:ext cx="3200400" cy="969264"/>
+          </a:xfrm>
+          <a:prstGeom prst="rect">
+            <a:avLst/>
+          </a:prstGeom>
+          <a:noFill/>
+          <a:ln/>
+        </p:spPr>
+        <p:txBody>
+          <a:bodyPr wrap="square" lIns="0" tIns="0" rIns="0" bIns="0" rtlCol="0" anchor="t"/>
+          <a:lstStyle/>
+          <a:p>
+            <a:pPr indent="0" marL="0">
+              <a:lnSpc>
+                <a:spcPct val="112000"/>
+              </a:lnSpc>
+              <a:buNone/>
+            </a:pPr>
+            <a:r>
+              <a:rPr lang="en-US" sz="1050" dirty="0">
+                <a:solidFill>
+                  <a:srgbClr val="5A7184"/>
+                </a:solidFill>
+                <a:latin typeface="Malgun Gothic" pitchFamily="34" charset="0"/>
+                <a:ea typeface="Malgun Gothic" pitchFamily="34" charset="-122"/>
+                <a:cs typeface="Malgun Gothic" pitchFamily="34" charset="-120"/>
+              </a:rPr>
+              <a:t>Host SW · Workload Integration · Solution Engineering · E2E Validation — 기술지원이 아니라 제품 기획·개발 참여</a:t>
+            </a:r>
+            <a:endParaRPr lang="en-US" sz="1050" dirty="0"/>
+          </a:p>
+        </p:txBody>
+      </p:sp>
+      <p:sp>
+        <p:nvSpPr>
+          <p:cNvPr id="27" name="Shape 21"/>
+          <p:cNvSpPr/>
+          <p:nvPr/>
+        </p:nvSpPr>
+        <p:spPr>
+          <a:xfrm>
+            <a:off x="4297680" y="3163824"/>
+            <a:ext cx="3602736" cy="1737360"/>
+          </a:xfrm>
+          <a:prstGeom prst="roundRect">
+            <a:avLst>
+              <a:gd name="adj" fmla="val 4737"/>
+            </a:avLst>
+          </a:prstGeom>
+          <a:solidFill>
+            <a:srgbClr val="F5F7F8"/>
+          </a:solidFill>
+          <a:ln/>
+        </p:spPr>
+      </p:sp>
+      <p:sp>
+        <p:nvSpPr>
+          <p:cNvPr id="28" name="Shape 22"/>
+          <p:cNvSpPr/>
+          <p:nvPr/>
+        </p:nvSpPr>
+        <p:spPr>
+          <a:xfrm>
+            <a:off x="4480560" y="3328416"/>
+            <a:ext cx="402336" cy="402336"/>
+          </a:xfrm>
+          <a:prstGeom prst="ellipse">
+            <a:avLst/>
+          </a:prstGeom>
+          <a:solidFill>
+            <a:srgbClr val="0E6BA8"/>
+          </a:solidFill>
+          <a:ln/>
+        </p:spPr>
+      </p:sp>
+      <p:pic>
+        <p:nvPicPr>
+          <p:cNvPr id="29" name="Image 4" descr="preencoded.png">    </p:cNvPr>
+          <p:cNvPicPr>
+            <a:picLocks noChangeAspect="1"/>
+          </p:cNvPicPr>
+          <p:nvPr/>
+        </p:nvPicPr>
+        <p:blipFill>
+          <a:blip r:embed="rId5"/>
+          <a:stretch>
+            <a:fillRect/>
+          </a:stretch>
+        </p:blipFill>
+        <p:spPr>
+          <a:xfrm>
+            <a:off x="4577121" y="3424977"/>
+            <a:ext cx="209215" cy="209215"/>
+          </a:xfrm>
+          <a:prstGeom prst="rect">
+            <a:avLst/>
+          </a:prstGeom>
+        </p:spPr>
+      </p:pic>
+      <p:sp>
+        <p:nvSpPr>
+          <p:cNvPr id="30" name="Text 23"/>
+          <p:cNvSpPr/>
+          <p:nvPr/>
+        </p:nvSpPr>
+        <p:spPr>
+          <a:xfrm>
+            <a:off x="4992624" y="3346704"/>
+            <a:ext cx="2743200" cy="365760"/>
+          </a:xfrm>
+          <a:prstGeom prst="rect">
+            <a:avLst/>
+          </a:prstGeom>
+          <a:noFill/>
+          <a:ln/>
+        </p:spPr>
+        <p:txBody>
+          <a:bodyPr wrap="square" lIns="0" tIns="0" rIns="0" bIns="0" rtlCol="0" anchor="ctr"/>
+          <a:lstStyle/>
+          <a:p>
+            <a:pPr indent="0" marL="0">
+              <a:buNone/>
+            </a:pPr>
+            <a:r>
+              <a:rPr lang="en-US" sz="1400" b="1" dirty="0">
+                <a:solidFill>
+                  <a:srgbClr val="17313B"/>
+                </a:solidFill>
+                <a:latin typeface="Malgun Gothic" pitchFamily="34" charset="0"/>
+                <a:ea typeface="Malgun Gothic" pitchFamily="34" charset="-122"/>
+                <a:cs typeface="Malgun Gothic" pitchFamily="34" charset="-120"/>
+              </a:rPr>
+              <a:t>5. Binding 계약 기술협력</a:t>
+            </a:r>
+            <a:endParaRPr lang="en-US" sz="1400" dirty="0"/>
+          </a:p>
+        </p:txBody>
+      </p:sp>
+      <p:sp>
+        <p:nvSpPr>
+          <p:cNvPr id="31" name="Text 24"/>
+          <p:cNvSpPr/>
+          <p:nvPr/>
+        </p:nvSpPr>
+        <p:spPr>
+          <a:xfrm>
+            <a:off x="4498848" y="3840480"/>
+            <a:ext cx="3200400" cy="969264"/>
+          </a:xfrm>
+          <a:prstGeom prst="rect">
+            <a:avLst/>
+          </a:prstGeom>
+          <a:noFill/>
+          <a:ln/>
+        </p:spPr>
+        <p:txBody>
+          <a:bodyPr wrap="square" lIns="0" tIns="0" rIns="0" bIns="0" rtlCol="0" anchor="t"/>
+          <a:lstStyle/>
+          <a:p>
+            <a:pPr indent="0" marL="0">
+              <a:lnSpc>
+                <a:spcPct val="112000"/>
+              </a:lnSpc>
+              <a:buNone/>
+            </a:pPr>
+            <a:r>
+              <a:rPr lang="en-US" sz="1050" dirty="0">
+                <a:solidFill>
+                  <a:srgbClr val="5A7184"/>
+                </a:solidFill>
+                <a:latin typeface="Malgun Gothic" pitchFamily="34" charset="0"/>
+                <a:ea typeface="Malgun Gothic" pitchFamily="34" charset="-122"/>
+                <a:cs typeface="Malgun Gothic" pitchFamily="34" charset="-120"/>
+              </a:rPr>
+              <a:t>고객: 물량·trace 제공·공동 로드맵 ↔ 삼성: 공급능력·SDK·개선 목표 — 공동 플랫폼 계약으로 확장</a:t>
+            </a:r>
+            <a:endParaRPr lang="en-US" sz="1050" dirty="0"/>
+          </a:p>
+        </p:txBody>
+      </p:sp>
+      <p:sp>
+        <p:nvSpPr>
+          <p:cNvPr id="32" name="Shape 25"/>
+          <p:cNvSpPr/>
+          <p:nvPr/>
+        </p:nvSpPr>
+        <p:spPr>
+          <a:xfrm>
+            <a:off x="8138160" y="3163824"/>
+            <a:ext cx="3602736" cy="1737360"/>
+          </a:xfrm>
+          <a:prstGeom prst="roundRect">
+            <a:avLst>
+              <a:gd name="adj" fmla="val 4737"/>
+            </a:avLst>
+          </a:prstGeom>
+          <a:solidFill>
+            <a:srgbClr val="F5F7F8"/>
+          </a:solidFill>
+          <a:ln/>
+        </p:spPr>
+      </p:sp>
+      <p:sp>
+        <p:nvSpPr>
+          <p:cNvPr id="33" name="Shape 26"/>
+          <p:cNvSpPr/>
+          <p:nvPr/>
+        </p:nvSpPr>
+        <p:spPr>
+          <a:xfrm>
+            <a:off x="8321040" y="3328416"/>
+            <a:ext cx="402336" cy="402336"/>
+          </a:xfrm>
+          <a:prstGeom prst="ellipse">
+            <a:avLst/>
+          </a:prstGeom>
+          <a:solidFill>
+            <a:srgbClr val="028090"/>
+          </a:solidFill>
+          <a:ln/>
+        </p:spPr>
+      </p:sp>
+      <p:pic>
+        <p:nvPicPr>
+          <p:cNvPr id="34" name="Image 5" descr="preencoded.png">    </p:cNvPr>
+          <p:cNvPicPr>
+            <a:picLocks noChangeAspect="1"/>
+          </p:cNvPicPr>
+          <p:nvPr/>
+        </p:nvPicPr>
+        <p:blipFill>
+          <a:blip r:embed="rId6"/>
+          <a:stretch>
+            <a:fillRect/>
+          </a:stretch>
+        </p:blipFill>
+        <p:spPr>
+          <a:xfrm>
+            <a:off x="8417601" y="3424977"/>
+            <a:ext cx="209215" cy="209215"/>
+          </a:xfrm>
+          <a:prstGeom prst="rect">
+            <a:avLst/>
+          </a:prstGeom>
+        </p:spPr>
+      </p:pic>
+      <p:sp>
+        <p:nvSpPr>
+          <p:cNvPr id="35" name="Text 27"/>
+          <p:cNvSpPr/>
+          <p:nvPr/>
+        </p:nvSpPr>
+        <p:spPr>
+          <a:xfrm>
+            <a:off x="8833104" y="3346704"/>
+            <a:ext cx="2743200" cy="365760"/>
+          </a:xfrm>
+          <a:prstGeom prst="rect">
+            <a:avLst/>
+          </a:prstGeom>
+          <a:noFill/>
+          <a:ln/>
+        </p:spPr>
+        <p:txBody>
+          <a:bodyPr wrap="square" lIns="0" tIns="0" rIns="0" bIns="0" rtlCol="0" anchor="ctr"/>
+          <a:lstStyle/>
+          <a:p>
+            <a:pPr indent="0" marL="0">
+              <a:buNone/>
+            </a:pPr>
+            <a:r>
+              <a:rPr lang="en-US" sz="1400" b="1" dirty="0">
+                <a:solidFill>
+                  <a:srgbClr val="17313B"/>
+                </a:solidFill>
+                <a:latin typeface="Malgun Gothic" pitchFamily="34" charset="0"/>
+                <a:ea typeface="Malgun Gothic" pitchFamily="34" charset="-122"/>
+                <a:cs typeface="Malgun Gothic" pitchFamily="34" charset="-120"/>
+              </a:rPr>
+              <a:t>6. 오픈소스·차별화 경계</a:t>
+            </a:r>
+            <a:endParaRPr lang="en-US" sz="1400" dirty="0"/>
+          </a:p>
+        </p:txBody>
+      </p:sp>
+      <p:sp>
+        <p:nvSpPr>
+          <p:cNvPr id="36" name="Text 28"/>
+          <p:cNvSpPr/>
+          <p:nvPr/>
+        </p:nvSpPr>
+        <p:spPr>
+          <a:xfrm>
+            <a:off x="8339328" y="3840480"/>
+            <a:ext cx="3200400" cy="969264"/>
+          </a:xfrm>
+          <a:prstGeom prst="rect">
+            <a:avLst/>
+          </a:prstGeom>
+          <a:noFill/>
+          <a:ln/>
+        </p:spPr>
+        <p:txBody>
+          <a:bodyPr wrap="square" lIns="0" tIns="0" rIns="0" bIns="0" rtlCol="0" anchor="t"/>
+          <a:lstStyle/>
+          <a:p>
+            <a:pPr indent="0" marL="0">
+              <a:lnSpc>
+                <a:spcPct val="112000"/>
+              </a:lnSpc>
+              <a:buNone/>
+            </a:pPr>
+            <a:r>
+              <a:rPr lang="en-US" sz="1050" dirty="0">
+                <a:solidFill>
+                  <a:srgbClr val="5A7184"/>
+                </a:solidFill>
+                <a:latin typeface="Malgun Gothic" pitchFamily="34" charset="0"/>
+                <a:ea typeface="Malgun Gothic" pitchFamily="34" charset="-122"/>
+                <a:cs typeface="Malgun Gothic" pitchFamily="34" charset="-120"/>
+              </a:rPr>
+              <a:t>공개: 기본 라이브러리·연동·적합성 테스트 / 차별화: NAND·FTL 모델·정책 추천·예측 모델 — lock-in 우려 해소</a:t>
+            </a:r>
+            <a:endParaRPr lang="en-US" sz="1050" dirty="0"/>
+          </a:p>
+        </p:txBody>
+      </p:sp>
+      <p:sp>
+        <p:nvSpPr>
+          <p:cNvPr id="37" name="Shape 29"/>
+          <p:cNvSpPr/>
+          <p:nvPr/>
+        </p:nvSpPr>
+        <p:spPr>
+          <a:xfrm>
+            <a:off x="457200" y="5175504"/>
+            <a:ext cx="11274552" cy="822960"/>
+          </a:xfrm>
+          <a:prstGeom prst="roundRect">
+            <a:avLst>
+              <a:gd name="adj" fmla="val 8889"/>
+            </a:avLst>
+          </a:prstGeom>
+          <a:solidFill>
+            <a:srgbClr val="E8F6F0"/>
+          </a:solidFill>
+          <a:ln w="15875">
+            <a:solidFill>
+              <a:srgbClr val="02A878"/>
+            </a:solidFill>
+            <a:prstDash val="solid"/>
+          </a:ln>
+        </p:spPr>
+      </p:sp>
+      <p:pic>
+        <p:nvPicPr>
+          <p:cNvPr id="38" name="Image 6" descr="preencoded.png">    </p:cNvPr>
+          <p:cNvPicPr>
+            <a:picLocks noChangeAspect="1"/>
+          </p:cNvPicPr>
+          <p:nvPr/>
+        </p:nvPicPr>
+        <p:blipFill>
+          <a:blip r:embed="rId7"/>
+          <a:stretch>
+            <a:fillRect/>
+          </a:stretch>
+        </p:blipFill>
+        <p:spPr>
+          <a:xfrm>
+            <a:off x="658368" y="5404104"/>
+            <a:ext cx="365760" cy="365760"/>
+          </a:xfrm>
+          <a:prstGeom prst="rect">
+            <a:avLst/>
+          </a:prstGeom>
+        </p:spPr>
+      </p:pic>
+      <p:sp>
+        <p:nvSpPr>
+          <p:cNvPr id="39" name="Text 30"/>
+          <p:cNvSpPr/>
+          <p:nvPr/>
+        </p:nvSpPr>
+        <p:spPr>
+          <a:xfrm>
+            <a:off x="1152144" y="5175504"/>
+            <a:ext cx="10424160" cy="822960"/>
+          </a:xfrm>
+          <a:prstGeom prst="rect">
+            <a:avLst/>
+          </a:prstGeom>
+          <a:noFill/>
+          <a:ln/>
+        </p:spPr>
+        <p:txBody>
+          <a:bodyPr wrap="square" lIns="0" tIns="0" rIns="0" bIns="0" rtlCol="0" anchor="ctr"/>
+          <a:lstStyle/>
+          <a:p>
+            <a:pPr indent="0" marL="0">
+              <a:lnSpc>
+                <a:spcPct val="112000"/>
+              </a:lnSpc>
+              <a:buNone/>
+            </a:pPr>
+            <a:r>
+              <a:rPr lang="en-US" sz="1450" b="1" dirty="0">
+                <a:solidFill>
+                  <a:srgbClr val="17313B"/>
+                </a:solidFill>
+                <a:latin typeface="Malgun Gothic" pitchFamily="34" charset="0"/>
+                <a:ea typeface="Malgun Gothic" pitchFamily="34" charset="-122"/>
+                <a:cs typeface="Malgun Gothic" pitchFamily="34" charset="-120"/>
+              </a:rPr>
+              <a:t>핵심 KPI — 고객 시스템에서 FDP가 실제 활성화된 SSD 용량</a:t>
+            </a:r>
+            <a:endParaRPr lang="en-US" sz="1450" dirty="0"/>
+          </a:p>
+          <a:p>
+            <a:pPr indent="0" marL="0">
+              <a:lnSpc>
+                <a:spcPct val="112000"/>
+              </a:lnSpc>
+              <a:buNone/>
+            </a:pPr>
+            <a:r>
+              <a:rPr lang="en-US" sz="1100" dirty="0">
+                <a:solidFill>
+                  <a:srgbClr val="5A7184"/>
+                </a:solidFill>
+                <a:latin typeface="Malgun Gothic" pitchFamily="34" charset="0"/>
+                <a:ea typeface="Malgun Gothic" pitchFamily="34" charset="-122"/>
+                <a:cs typeface="Malgun Gothic" pitchFamily="34" charset="-120"/>
+              </a:rPr>
+              <a:t>지원 SSD 출하량만 세면 미사용 기능이 된다 · Captive SSD 계획에서 삼성 완제품으로 전환된 물량을 병행 추적 · WAF·p999·usable capacity 개선율</a:t>
+            </a:r>
+            <a:endParaRPr lang="en-US" sz="1450" dirty="0"/>
+          </a:p>
+        </p:txBody>
+      </p:sp>
+      <p:sp>
+        <p:nvSpPr>
+          <p:cNvPr id="40" name="Text 31"/>
+          <p:cNvSpPr/>
+          <p:nvPr/>
+        </p:nvSpPr>
+        <p:spPr>
+          <a:xfrm>
+            <a:off x="457200" y="6108192"/>
+            <a:ext cx="11274552" cy="256032"/>
+          </a:xfrm>
+          <a:prstGeom prst="rect">
+            <a:avLst/>
+          </a:prstGeom>
+          <a:noFill/>
+          <a:ln/>
+        </p:spPr>
+        <p:txBody>
+          <a:bodyPr wrap="square" lIns="0" tIns="0" rIns="0" bIns="0" rtlCol="0" anchor="ctr"/>
+          <a:lstStyle/>
+          <a:p>
+            <a:pPr algn="ctr" indent="0" marL="0">
+              <a:buNone/>
+            </a:pPr>
+            <a:r>
+              <a:rPr lang="en-US" sz="1200" i="1" dirty="0">
+                <a:solidFill>
+                  <a:srgbClr val="5A7184"/>
+                </a:solidFill>
+                <a:latin typeface="Malgun Gothic" pitchFamily="34" charset="0"/>
+                <a:ea typeface="Malgun Gothic" pitchFamily="34" charset="-122"/>
+                <a:cs typeface="Malgun Gothic" pitchFamily="34" charset="-120"/>
+              </a:rPr>
+              <a:t>실행 주체: 인재 축(FDE 스타)이 이 플랫폼을 들고 고객 아키텍처 안으로 들어간다</a:t>
+            </a:r>
+            <a:endParaRPr lang="en-US" sz="1200" dirty="0"/>
           </a:p>
         </p:txBody>
       </p:sp>

</xml_diff>